<commit_message>
feat(ocr): Tích hợp hệ thống SGK OCR 4-stage pipeline, skill sgk-ocr và cập nhật quy chuẩn AGENTS.md
</commit_message>
<xml_diff>
--- a/KHBD_Tin_học/Tiền_tiểu_học/Tuần_04/Slide_Tin_hoc_Tiền_tiểu_học_Tiet03_Em_ngoi_may_tinh_an_toan.pptx
+++ b/KHBD_Tin_học/Tiền_tiểu_học/Tuần_04/Slide_Tin_hoc_Tiền_tiểu_học_Tiet03_Em_ngoi_may_tinh_an_toan.pptx
@@ -6,15 +6,12 @@
   </p:sldMasterIdLst>
   <p:sldIdLst>
     <p:sldId id="256" r:id="rId2"/>
-    <p:sldId id="258" r:id="rId3"/>
-    <p:sldId id="259" r:id="rId4"/>
-    <p:sldId id="257" r:id="rId5"/>
-    <p:sldId id="260" r:id="rId10"/>
-    <p:sldId id="261" r:id="rId11"/>
-    <p:sldId id="262" r:id="rId12"/>
-    <p:sldId id="263" r:id="rId13"/>
-    <p:sldId id="264" r:id="rId14"/>
-    <p:sldId id="265" r:id="rId15"/>
+    <p:sldId id="260" r:id="rId3"/>
+    <p:sldId id="261" r:id="rId4"/>
+    <p:sldId id="262" r:id="rId5"/>
+    <p:sldId id="263" r:id="rId6"/>
+    <p:sldId id="264" r:id="rId7"/>
+    <p:sldId id="265" r:id="rId8"/>
   </p:sldIdLst>
   <p:sldSz cx="12192000" cy="6858000"/>
   <p:notesSz cx="6858000" cy="9144000"/>
@@ -113,6 +110,11 @@
       </a:defRPr>
     </a:lvl9pPr>
   </p:defaultTextStyle>
+  <p:extLst>
+    <p:ext uri="{EFAFB233-063F-42B5-8137-9DF3F51BA10A}">
+      <p15:sldGuideLst xmlns:p15="http://schemas.microsoft.com/office/powerpoint/2012/main"/>
+    </p:ext>
+  </p:extLst>
 </p:presentation>
 </file>
 
@@ -263,7 +265,7 @@
           <a:p>
             <a:fld id="{4EA7EFA5-8E37-463D-AE92-97FC5095B482}" type="datetimeFigureOut">
               <a:rPr lang="en-US" smtClean="0"/>
-              <a:t>8/4/2026</a:t>
+              <a:t>8/26/2026</a:t>
             </a:fld>
             <a:endParaRPr lang="en-US"/>
           </a:p>
@@ -461,7 +463,7 @@
           <a:p>
             <a:fld id="{4EA7EFA5-8E37-463D-AE92-97FC5095B482}" type="datetimeFigureOut">
               <a:rPr lang="en-US" smtClean="0"/>
-              <a:t>8/4/2026</a:t>
+              <a:t>8/26/2026</a:t>
             </a:fld>
             <a:endParaRPr lang="en-US"/>
           </a:p>
@@ -669,7 +671,7 @@
           <a:p>
             <a:fld id="{4EA7EFA5-8E37-463D-AE92-97FC5095B482}" type="datetimeFigureOut">
               <a:rPr lang="en-US" smtClean="0"/>
-              <a:t>8/4/2026</a:t>
+              <a:t>8/26/2026</a:t>
             </a:fld>
             <a:endParaRPr lang="en-US"/>
           </a:p>
@@ -867,7 +869,7 @@
           <a:p>
             <a:fld id="{4EA7EFA5-8E37-463D-AE92-97FC5095B482}" type="datetimeFigureOut">
               <a:rPr lang="en-US" smtClean="0"/>
-              <a:t>8/4/2026</a:t>
+              <a:t>8/26/2026</a:t>
             </a:fld>
             <a:endParaRPr lang="en-US"/>
           </a:p>
@@ -1142,7 +1144,7 @@
           <a:p>
             <a:fld id="{4EA7EFA5-8E37-463D-AE92-97FC5095B482}" type="datetimeFigureOut">
               <a:rPr lang="en-US" smtClean="0"/>
-              <a:t>8/4/2026</a:t>
+              <a:t>8/26/2026</a:t>
             </a:fld>
             <a:endParaRPr lang="en-US"/>
           </a:p>
@@ -1407,7 +1409,7 @@
           <a:p>
             <a:fld id="{4EA7EFA5-8E37-463D-AE92-97FC5095B482}" type="datetimeFigureOut">
               <a:rPr lang="en-US" smtClean="0"/>
-              <a:t>8/4/2026</a:t>
+              <a:t>8/26/2026</a:t>
             </a:fld>
             <a:endParaRPr lang="en-US"/>
           </a:p>
@@ -1819,7 +1821,7 @@
           <a:p>
             <a:fld id="{4EA7EFA5-8E37-463D-AE92-97FC5095B482}" type="datetimeFigureOut">
               <a:rPr lang="en-US" smtClean="0"/>
-              <a:t>8/4/2026</a:t>
+              <a:t>8/26/2026</a:t>
             </a:fld>
             <a:endParaRPr lang="en-US"/>
           </a:p>
@@ -1960,7 +1962,7 @@
           <a:p>
             <a:fld id="{4EA7EFA5-8E37-463D-AE92-97FC5095B482}" type="datetimeFigureOut">
               <a:rPr lang="en-US" smtClean="0"/>
-              <a:t>8/4/2026</a:t>
+              <a:t>8/26/2026</a:t>
             </a:fld>
             <a:endParaRPr lang="en-US"/>
           </a:p>
@@ -2073,7 +2075,7 @@
           <a:p>
             <a:fld id="{4EA7EFA5-8E37-463D-AE92-97FC5095B482}" type="datetimeFigureOut">
               <a:rPr lang="en-US" smtClean="0"/>
-              <a:t>8/4/2026</a:t>
+              <a:t>8/26/2026</a:t>
             </a:fld>
             <a:endParaRPr lang="en-US"/>
           </a:p>
@@ -2384,7 +2386,7 @@
           <a:p>
             <a:fld id="{4EA7EFA5-8E37-463D-AE92-97FC5095B482}" type="datetimeFigureOut">
               <a:rPr lang="en-US" smtClean="0"/>
-              <a:t>8/4/2026</a:t>
+              <a:t>8/26/2026</a:t>
             </a:fld>
             <a:endParaRPr lang="en-US"/>
           </a:p>
@@ -2672,7 +2674,7 @@
           <a:p>
             <a:fld id="{4EA7EFA5-8E37-463D-AE92-97FC5095B482}" type="datetimeFigureOut">
               <a:rPr lang="en-US" smtClean="0"/>
-              <a:t>8/4/2026</a:t>
+              <a:t>8/26/2026</a:t>
             </a:fld>
             <a:endParaRPr lang="en-US"/>
           </a:p>
@@ -2913,7 +2915,7 @@
           <a:p>
             <a:fld id="{4EA7EFA5-8E37-463D-AE92-97FC5095B482}" type="datetimeFigureOut">
               <a:rPr lang="en-US" smtClean="0"/>
-              <a:t>8/4/2026</a:t>
+              <a:t>8/26/2026</a:t>
             </a:fld>
             <a:endParaRPr lang="en-US"/>
           </a:p>
@@ -3499,142 +3501,6 @@
 </p:sld>
 </file>
 
-<file path=ppt/slides/slide10.xml><?xml version="1.0" encoding="utf-8"?>
-<p:sld xmlns:a="http://schemas.openxmlformats.org/drawingml/2006/main" xmlns:p="http://schemas.openxmlformats.org/presentationml/2006/main" xmlns:r="http://schemas.openxmlformats.org/officeDocument/2006/relationships">
-  <p:cSld>
-    <p:spTree>
-      <p:nvGrpSpPr>
-        <p:cNvPr id="1" name=""/>
-        <p:cNvGrpSpPr/>
-        <p:nvPr/>
-      </p:nvGrpSpPr>
-      <p:grpSpPr/>
-      <p:sp>
-        <p:nvSpPr>
-          <p:cNvPr id="2" name="Rectangle 1"/>
-          <p:cNvSpPr/>
-          <p:nvPr/>
-        </p:nvSpPr>
-        <p:spPr>
-          <a:xfrm>
-            <a:off x="0" y="1051560"/>
-            <a:ext cx="12188952" cy="4754879"/>
-          </a:xfrm>
-          <a:prstGeom prst="rect">
-            <a:avLst/>
-          </a:prstGeom>
-          <a:solidFill>
-            <a:srgbClr val="1B4F9B"/>
-          </a:solidFill>
-          <a:ln>
-            <a:noFill/>
-          </a:ln>
-        </p:spPr>
-        <p:style>
-          <a:lnRef idx="1">
-            <a:schemeClr val="accent1"/>
-          </a:lnRef>
-          <a:fillRef idx="3">
-            <a:schemeClr val="accent1"/>
-          </a:fillRef>
-          <a:effectRef idx="2">
-            <a:schemeClr val="accent1"/>
-          </a:effectRef>
-          <a:fontRef idx="minor">
-            <a:schemeClr val="lt1"/>
-          </a:fontRef>
-        </p:style>
-        <p:txBody>
-          <a:bodyPr rtlCol="0" anchor="ctr"/>
-          <a:lstStyle/>
-          <a:p>
-            <a:pPr algn="ctr"/>
-          </a:p>
-        </p:txBody>
-      </p:sp>
-      <p:sp>
-        <p:nvSpPr>
-          <p:cNvPr id="3" name="TextBox 2"/>
-          <p:cNvSpPr txBox="1"/>
-          <p:nvPr/>
-        </p:nvSpPr>
-        <p:spPr>
-          <a:xfrm>
-            <a:off x="914400" y="1828800"/>
-            <a:ext cx="10360152" cy="1097280"/>
-          </a:xfrm>
-          <a:prstGeom prst="rect">
-            <a:avLst/>
-          </a:prstGeom>
-          <a:noFill/>
-        </p:spPr>
-        <p:txBody>
-          <a:bodyPr wrap="square" lIns="73152" rIns="73152">
-            <a:spAutoFit/>
-          </a:bodyPr>
-          <a:lstStyle/>
-          <a:p>
-            <a:pPr algn="ctr">
-              <a:defRPr sz="3600" b="1">
-                <a:solidFill>
-                  <a:srgbClr val="FFFFFF"/>
-                </a:solidFill>
-                <a:latin typeface="Arial"/>
-              </a:defRPr>
-            </a:pPr>
-            <a:r>
-              <a:t>Các con giỏi lắm! 🌟</a:t>
-            </a:r>
-          </a:p>
-        </p:txBody>
-      </p:sp>
-      <p:sp>
-        <p:nvSpPr>
-          <p:cNvPr id="4" name="TextBox 3"/>
-          <p:cNvSpPr txBox="1"/>
-          <p:nvPr/>
-        </p:nvSpPr>
-        <p:spPr>
-          <a:xfrm>
-            <a:off x="914400" y="3200400"/>
-            <a:ext cx="10360152" cy="914400"/>
-          </a:xfrm>
-          <a:prstGeom prst="rect">
-            <a:avLst/>
-          </a:prstGeom>
-          <a:noFill/>
-        </p:spPr>
-        <p:txBody>
-          <a:bodyPr wrap="square" lIns="73152" rIns="73152">
-            <a:spAutoFit/>
-          </a:bodyPr>
-          <a:lstStyle/>
-          <a:p>
-            <a:pPr algn="ctr">
-              <a:defRPr sz="2200" b="0">
-                <a:solidFill>
-                  <a:srgbClr val="FFFFFF"/>
-                </a:solidFill>
-                <a:latin typeface="Arial"/>
-              </a:defRPr>
-            </a:pPr>
-            <a:r>
-              <a:t>BTVN: Hãy nhắc nhở bố mẹ và anh chị ngồi đúng tư thế nhé!</a:t>
-            </a:r>
-          </a:p>
-        </p:txBody>
-      </p:sp>
-    </p:spTree>
-  </p:cSld>
-  <p:clrMapOvr>
-    <a:masterClrMapping/>
-  </p:clrMapOvr>
-  <p:transition spd="med">
-    <p:fade/>
-  </p:transition>
-</p:sld>
-</file>
-
 <file path=ppt/slides/slide2.xml><?xml version="1.0" encoding="utf-8"?>
 <p:sld xmlns:a="http://schemas.openxmlformats.org/drawingml/2006/main" xmlns:r="http://schemas.openxmlformats.org/officeDocument/2006/relationships" xmlns:p="http://schemas.openxmlformats.org/presentationml/2006/main">
   <p:cSld>
@@ -3654,100 +3520,172 @@
       </p:grpSpPr>
       <p:sp>
         <p:nvSpPr>
-          <p:cNvPr id="2" name="Title 1">
-            <a:extLst>
-              <a:ext uri="{FF2B5EF4-FFF2-40B4-BE49-F238E27FC236}">
-                <a16:creationId xmlns:a16="http://schemas.microsoft.com/office/drawing/2014/main" id="{19A0AB71-A960-5C29-67C4-E061282DF716}"/>
-              </a:ext>
-            </a:extLst>
-          </p:cNvPr>
-          <p:cNvSpPr>
-            <a:spLocks noGrp="1"/>
-          </p:cNvSpPr>
-          <p:nvPr>
-            <p:ph type="title"/>
-          </p:nvPr>
-        </p:nvSpPr>
-        <p:spPr>
-          <a:xfrm>
-            <a:off x="3930315" y="215531"/>
-            <a:ext cx="3826042" cy="861546"/>
-          </a:xfrm>
-        </p:spPr>
-        <p:txBody>
-          <a:bodyPr>
-            <a:normAutofit/>
+          <p:cNvPr id="3" name="Rectangle 2"/>
+          <p:cNvSpPr/>
+          <p:nvPr/>
+        </p:nvSpPr>
+        <p:spPr>
+          <a:xfrm>
+            <a:off x="0" y="1051560"/>
+            <a:ext cx="12188952" cy="1645920"/>
+          </a:xfrm>
+          <a:prstGeom prst="rect">
+            <a:avLst/>
+          </a:prstGeom>
+          <a:solidFill>
+            <a:srgbClr val="2D7DD2"/>
+          </a:solidFill>
+          <a:ln>
+            <a:noFill/>
+          </a:ln>
+        </p:spPr>
+        <p:style>
+          <a:lnRef idx="1">
+            <a:schemeClr val="accent1"/>
+          </a:lnRef>
+          <a:fillRef idx="3">
+            <a:schemeClr val="accent1"/>
+          </a:fillRef>
+          <a:effectRef idx="2">
+            <a:schemeClr val="accent1"/>
+          </a:effectRef>
+          <a:fontRef idx="minor">
+            <a:schemeClr val="lt1"/>
+          </a:fontRef>
+        </p:style>
+        <p:txBody>
+          <a:bodyPr rtlCol="0" anchor="ctr"/>
+          <a:lstStyle/>
+          <a:p>
+            <a:pPr algn="ctr"/>
+            <a:endParaRPr/>
+          </a:p>
+        </p:txBody>
+      </p:sp>
+      <p:sp>
+        <p:nvSpPr>
+          <p:cNvPr id="2" name="Rectangle 1"/>
+          <p:cNvSpPr/>
+          <p:nvPr/>
+        </p:nvSpPr>
+        <p:spPr>
+          <a:xfrm>
+            <a:off x="0" y="1051560"/>
+            <a:ext cx="12188952" cy="4754879"/>
+          </a:xfrm>
+          <a:prstGeom prst="rect">
+            <a:avLst/>
+          </a:prstGeom>
+          <a:solidFill>
+            <a:srgbClr val="1B4F9B"/>
+          </a:solidFill>
+          <a:ln>
+            <a:noFill/>
+          </a:ln>
+        </p:spPr>
+        <p:style>
+          <a:lnRef idx="1">
+            <a:schemeClr val="accent1"/>
+          </a:lnRef>
+          <a:fillRef idx="3">
+            <a:schemeClr val="accent1"/>
+          </a:fillRef>
+          <a:effectRef idx="2">
+            <a:schemeClr val="accent1"/>
+          </a:effectRef>
+          <a:fontRef idx="minor">
+            <a:schemeClr val="lt1"/>
+          </a:fontRef>
+        </p:style>
+        <p:txBody>
+          <a:bodyPr rtlCol="0" anchor="ctr"/>
+          <a:lstStyle/>
+          <a:p>
+            <a:pPr algn="ctr"/>
+            <a:endParaRPr/>
+          </a:p>
+        </p:txBody>
+      </p:sp>
+      <p:sp>
+        <p:nvSpPr>
+          <p:cNvPr id="4" name="TextBox 3"/>
+          <p:cNvSpPr txBox="1"/>
+          <p:nvPr/>
+        </p:nvSpPr>
+        <p:spPr>
+          <a:xfrm>
+            <a:off x="731520" y="1828800"/>
+            <a:ext cx="6858000" cy="1371600"/>
+          </a:xfrm>
+          <a:prstGeom prst="rect">
+            <a:avLst/>
+          </a:prstGeom>
+          <a:noFill/>
+        </p:spPr>
+        <p:txBody>
+          <a:bodyPr wrap="square" lIns="73152" rIns="73152">
+            <a:spAutoFit/>
           </a:bodyPr>
           <a:lstStyle/>
           <a:p>
-            <a:r>
-              <a:rPr lang="en-US" dirty="0">
+            <a:pPr algn="l">
+              <a:defRPr sz="3400" b="1">
                 <a:solidFill>
-                  <a:schemeClr val="tx2">
-                    <a:lumMod val="75000"/>
-                    <a:lumOff val="25000"/>
-                  </a:schemeClr>
+                  <a:srgbClr val="FFFFFF"/>
                 </a:solidFill>
-              </a:rPr>
-              <a:t>Môn Tin </a:t>
-            </a:r>
-            <a:r>
-              <a:rPr lang="en-US" dirty="0" err="1">
+                <a:latin typeface="Arial"/>
+              </a:defRPr>
+            </a:pPr>
+            <a:r>
+              <a:t>Em ngồi máy tính an toàn 🪑</a:t>
+            </a:r>
+          </a:p>
+        </p:txBody>
+      </p:sp>
+      <p:sp>
+        <p:nvSpPr>
+          <p:cNvPr id="5" name="TextBox 4"/>
+          <p:cNvSpPr txBox="1"/>
+          <p:nvPr/>
+        </p:nvSpPr>
+        <p:spPr>
+          <a:xfrm>
+            <a:off x="731520" y="3474720"/>
+            <a:ext cx="6858000" cy="731519"/>
+          </a:xfrm>
+          <a:prstGeom prst="rect">
+            <a:avLst/>
+          </a:prstGeom>
+          <a:noFill/>
+        </p:spPr>
+        <p:txBody>
+          <a:bodyPr wrap="square" lIns="73152" rIns="73152">
+            <a:spAutoFit/>
+          </a:bodyPr>
+          <a:lstStyle/>
+          <a:p>
+            <a:pPr algn="l">
+              <a:defRPr sz="2000" b="0">
                 <a:solidFill>
-                  <a:schemeClr val="tx2">
-                    <a:lumMod val="75000"/>
-                    <a:lumOff val="25000"/>
-                  </a:schemeClr>
+                  <a:srgbClr val="FFFFFF"/>
                 </a:solidFill>
-              </a:rPr>
-              <a:t>học</a:t>
-            </a:r>
-            <a:r>
-              <a:rPr lang="en-US" dirty="0">
-                <a:solidFill>
-                  <a:schemeClr val="tx2">
-                    <a:lumMod val="75000"/>
-                    <a:lumOff val="25000"/>
-                  </a:schemeClr>
-                </a:solidFill>
-              </a:rPr>
-              <a:t> </a:t>
-            </a:r>
-            <a:r>
-              <a:rPr lang="en-US" dirty="0" err="1">
-                <a:solidFill>
-                  <a:schemeClr val="tx2">
-                    <a:lumMod val="75000"/>
-                    <a:lumOff val="25000"/>
-                  </a:schemeClr>
-                </a:solidFill>
-              </a:rPr>
-              <a:t>lớp</a:t>
-            </a:r>
-            <a:r>
-              <a:rPr lang="en-US" dirty="0">
-                <a:solidFill>
-                  <a:schemeClr val="tx2">
-                    <a:lumMod val="75000"/>
-                    <a:lumOff val="25000"/>
-                  </a:schemeClr>
-                </a:solidFill>
-              </a:rPr>
-              <a:t> </a:t>
+                <a:latin typeface="Arial"/>
+              </a:defRPr>
+            </a:pPr>
+            <a:r>
+              <a:t>Tin học • Tiền Tiểu học • Tiết 3</a:t>
             </a:r>
           </a:p>
         </p:txBody>
       </p:sp>
     </p:spTree>
-    <p:extLst>
-      <p:ext uri="{BB962C8B-B14F-4D97-AF65-F5344CB8AC3E}">
-        <p14:creationId xmlns:p14="http://schemas.microsoft.com/office/powerpoint/2010/main" val="2914658586"/>
-      </p:ext>
-    </p:extLst>
   </p:cSld>
   <p:clrMapOvr>
     <a:masterClrMapping/>
   </p:clrMapOvr>
+  <p:transition spd="med">
+    <p:fade/>
+  </p:transition>
 </p:sld>
 </file>
 
@@ -3756,13 +3694,7 @@
   <p:cSld>
     <p:spTree>
       <p:nvGrpSpPr>
-        <p:cNvPr id="1" name="">
-          <a:extLst>
-            <a:ext uri="{FF2B5EF4-FFF2-40B4-BE49-F238E27FC236}">
-              <a16:creationId xmlns:a16="http://schemas.microsoft.com/office/drawing/2014/main" id="{D3F3F47A-2A03-62D2-8A5D-F03932A437A1}"/>
-            </a:ext>
-          </a:extLst>
-        </p:cNvPr>
+        <p:cNvPr id="1" name=""/>
         <p:cNvGrpSpPr/>
         <p:nvPr/>
       </p:nvGrpSpPr>
@@ -3776,100 +3708,706 @@
       </p:grpSpPr>
       <p:sp>
         <p:nvSpPr>
-          <p:cNvPr id="2" name="Title 1">
-            <a:extLst>
-              <a:ext uri="{FF2B5EF4-FFF2-40B4-BE49-F238E27FC236}">
-                <a16:creationId xmlns:a16="http://schemas.microsoft.com/office/drawing/2014/main" id="{32DE052A-67C4-3C30-0BE8-A144FDC576E8}"/>
-              </a:ext>
-            </a:extLst>
-          </p:cNvPr>
-          <p:cNvSpPr>
-            <a:spLocks noGrp="1"/>
-          </p:cNvSpPr>
-          <p:nvPr>
-            <p:ph type="title"/>
-          </p:nvPr>
-        </p:nvSpPr>
-        <p:spPr>
-          <a:xfrm>
-            <a:off x="3605463" y="335847"/>
-            <a:ext cx="3826042" cy="861546"/>
-          </a:xfrm>
-        </p:spPr>
-        <p:txBody>
-          <a:bodyPr>
-            <a:normAutofit/>
+          <p:cNvPr id="2" name="Rectangle 1"/>
+          <p:cNvSpPr/>
+          <p:nvPr/>
+        </p:nvSpPr>
+        <p:spPr>
+          <a:xfrm>
+            <a:off x="0" y="1051560"/>
+            <a:ext cx="12188952" cy="4754879"/>
+          </a:xfrm>
+          <a:prstGeom prst="rect">
+            <a:avLst/>
+          </a:prstGeom>
+          <a:solidFill>
+            <a:srgbClr val="EBF3FE"/>
+          </a:solidFill>
+          <a:ln>
+            <a:noFill/>
+          </a:ln>
+        </p:spPr>
+        <p:style>
+          <a:lnRef idx="1">
+            <a:schemeClr val="accent1"/>
+          </a:lnRef>
+          <a:fillRef idx="3">
+            <a:schemeClr val="accent1"/>
+          </a:fillRef>
+          <a:effectRef idx="2">
+            <a:schemeClr val="accent1"/>
+          </a:effectRef>
+          <a:fontRef idx="minor">
+            <a:schemeClr val="lt1"/>
+          </a:fontRef>
+        </p:style>
+        <p:txBody>
+          <a:bodyPr rtlCol="0" anchor="ctr"/>
+          <a:lstStyle/>
+          <a:p>
+            <a:pPr algn="ctr"/>
+            <a:endParaRPr/>
+          </a:p>
+        </p:txBody>
+      </p:sp>
+      <p:sp>
+        <p:nvSpPr>
+          <p:cNvPr id="3" name="Rectangle 2"/>
+          <p:cNvSpPr/>
+          <p:nvPr/>
+        </p:nvSpPr>
+        <p:spPr>
+          <a:xfrm>
+            <a:off x="0" y="1097280"/>
+            <a:ext cx="12188952" cy="411479"/>
+          </a:xfrm>
+          <a:prstGeom prst="rect">
+            <a:avLst/>
+          </a:prstGeom>
+          <a:solidFill>
+            <a:srgbClr val="1B4F9B"/>
+          </a:solidFill>
+          <a:ln>
+            <a:noFill/>
+          </a:ln>
+        </p:spPr>
+        <p:style>
+          <a:lnRef idx="1">
+            <a:schemeClr val="accent1"/>
+          </a:lnRef>
+          <a:fillRef idx="3">
+            <a:schemeClr val="accent1"/>
+          </a:fillRef>
+          <a:effectRef idx="2">
+            <a:schemeClr val="accent1"/>
+          </a:effectRef>
+          <a:fontRef idx="minor">
+            <a:schemeClr val="lt1"/>
+          </a:fontRef>
+        </p:style>
+        <p:txBody>
+          <a:bodyPr rtlCol="0" anchor="ctr"/>
+          <a:lstStyle/>
+          <a:p>
+            <a:pPr algn="ctr"/>
+            <a:endParaRPr/>
+          </a:p>
+        </p:txBody>
+      </p:sp>
+      <p:sp>
+        <p:nvSpPr>
+          <p:cNvPr id="4" name="TextBox 3"/>
+          <p:cNvSpPr txBox="1"/>
+          <p:nvPr/>
+        </p:nvSpPr>
+        <p:spPr>
+          <a:xfrm>
+            <a:off x="274320" y="1124712"/>
+            <a:ext cx="11640312" cy="365759"/>
+          </a:xfrm>
+          <a:prstGeom prst="rect">
+            <a:avLst/>
+          </a:prstGeom>
+          <a:noFill/>
+        </p:spPr>
+        <p:txBody>
+          <a:bodyPr wrap="square" lIns="73152" rIns="73152">
+            <a:spAutoFit/>
           </a:bodyPr>
           <a:lstStyle/>
           <a:p>
-            <a:r>
-              <a:rPr lang="en-US" dirty="0">
+            <a:pPr algn="l">
+              <a:defRPr sz="1300" b="1">
                 <a:solidFill>
-                  <a:schemeClr val="tx2">
-                    <a:lumMod val="75000"/>
-                    <a:lumOff val="25000"/>
-                  </a:schemeClr>
+                  <a:srgbClr val="FFFFFF"/>
                 </a:solidFill>
-              </a:rPr>
-              <a:t>Môn Tin </a:t>
-            </a:r>
-            <a:r>
-              <a:rPr lang="en-US" dirty="0" err="1">
+                <a:latin typeface="Arial"/>
+              </a:defRPr>
+            </a:pPr>
+            <a:r>
+              <a:t>  TIỀN TIỂU HỌC • KHÁM PHÁ BÀI HỌC</a:t>
+            </a:r>
+          </a:p>
+        </p:txBody>
+      </p:sp>
+      <p:sp>
+        <p:nvSpPr>
+          <p:cNvPr id="5" name="TextBox 4"/>
+          <p:cNvSpPr txBox="1"/>
+          <p:nvPr/>
+        </p:nvSpPr>
+        <p:spPr>
+          <a:xfrm>
+            <a:off x="457200" y="1600200"/>
+            <a:ext cx="11274552" cy="594359"/>
+          </a:xfrm>
+          <a:prstGeom prst="rect">
+            <a:avLst/>
+          </a:prstGeom>
+          <a:noFill/>
+        </p:spPr>
+        <p:txBody>
+          <a:bodyPr wrap="square" lIns="73152" rIns="73152">
+            <a:spAutoFit/>
+          </a:bodyPr>
+          <a:lstStyle/>
+          <a:p>
+            <a:pPr algn="l">
+              <a:defRPr sz="2600" b="1">
                 <a:solidFill>
-                  <a:schemeClr val="tx2">
-                    <a:lumMod val="75000"/>
-                    <a:lumOff val="25000"/>
-                  </a:schemeClr>
+                  <a:srgbClr val="1A2744"/>
                 </a:solidFill>
-              </a:rPr>
-              <a:t>học</a:t>
-            </a:r>
-            <a:r>
-              <a:rPr lang="en-US" dirty="0">
+                <a:latin typeface="Arial"/>
+              </a:defRPr>
+            </a:pPr>
+            <a:r>
+              <a:t>Bạn nào ngồi học đúng tư thế?</a:t>
+            </a:r>
+          </a:p>
+        </p:txBody>
+      </p:sp>
+      <p:sp>
+        <p:nvSpPr>
+          <p:cNvPr id="6" name="Rounded Rectangle 5"/>
+          <p:cNvSpPr/>
+          <p:nvPr/>
+        </p:nvSpPr>
+        <p:spPr>
+          <a:xfrm>
+            <a:off x="457200" y="2331720"/>
+            <a:ext cx="3474720" cy="3291840"/>
+          </a:xfrm>
+          <a:prstGeom prst="roundRect">
+            <a:avLst/>
+          </a:prstGeom>
+          <a:solidFill>
+            <a:srgbClr val="FFFFFF"/>
+          </a:solidFill>
+          <a:ln w="19050">
+            <a:solidFill>
+              <a:srgbClr val="DC2626"/>
+            </a:solidFill>
+          </a:ln>
+        </p:spPr>
+        <p:style>
+          <a:lnRef idx="1">
+            <a:schemeClr val="accent1"/>
+          </a:lnRef>
+          <a:fillRef idx="3">
+            <a:schemeClr val="accent1"/>
+          </a:fillRef>
+          <a:effectRef idx="2">
+            <a:schemeClr val="accent1"/>
+          </a:effectRef>
+          <a:fontRef idx="minor">
+            <a:schemeClr val="lt1"/>
+          </a:fontRef>
+        </p:style>
+        <p:txBody>
+          <a:bodyPr rtlCol="0" anchor="ctr"/>
+          <a:lstStyle/>
+          <a:p>
+            <a:pPr algn="ctr"/>
+            <a:endParaRPr/>
+          </a:p>
+        </p:txBody>
+      </p:sp>
+      <p:sp>
+        <p:nvSpPr>
+          <p:cNvPr id="7" name="Rectangle 6"/>
+          <p:cNvSpPr/>
+          <p:nvPr/>
+        </p:nvSpPr>
+        <p:spPr>
+          <a:xfrm>
+            <a:off x="457200" y="2331720"/>
+            <a:ext cx="3474720" cy="411480"/>
+          </a:xfrm>
+          <a:prstGeom prst="rect">
+            <a:avLst/>
+          </a:prstGeom>
+          <a:solidFill>
+            <a:srgbClr val="DC2626"/>
+          </a:solidFill>
+          <a:ln>
+            <a:noFill/>
+          </a:ln>
+        </p:spPr>
+        <p:style>
+          <a:lnRef idx="1">
+            <a:schemeClr val="accent1"/>
+          </a:lnRef>
+          <a:fillRef idx="3">
+            <a:schemeClr val="accent1"/>
+          </a:fillRef>
+          <a:effectRef idx="2">
+            <a:schemeClr val="accent1"/>
+          </a:effectRef>
+          <a:fontRef idx="minor">
+            <a:schemeClr val="lt1"/>
+          </a:fontRef>
+        </p:style>
+        <p:txBody>
+          <a:bodyPr rtlCol="0" anchor="ctr"/>
+          <a:lstStyle/>
+          <a:p>
+            <a:pPr algn="ctr"/>
+            <a:endParaRPr/>
+          </a:p>
+        </p:txBody>
+      </p:sp>
+      <p:sp>
+        <p:nvSpPr>
+          <p:cNvPr id="8" name="TextBox 7"/>
+          <p:cNvSpPr txBox="1"/>
+          <p:nvPr/>
+        </p:nvSpPr>
+        <p:spPr>
+          <a:xfrm>
+            <a:off x="457200" y="2377439"/>
+            <a:ext cx="3474720" cy="365759"/>
+          </a:xfrm>
+          <a:prstGeom prst="rect">
+            <a:avLst/>
+          </a:prstGeom>
+          <a:noFill/>
+        </p:spPr>
+        <p:txBody>
+          <a:bodyPr wrap="square" lIns="73152" rIns="73152">
+            <a:spAutoFit/>
+          </a:bodyPr>
+          <a:lstStyle/>
+          <a:p>
+            <a:pPr algn="ctr">
+              <a:defRPr sz="1800" b="1">
                 <a:solidFill>
-                  <a:schemeClr val="tx2">
-                    <a:lumMod val="75000"/>
-                    <a:lumOff val="25000"/>
-                  </a:schemeClr>
+                  <a:srgbClr val="FFFFFF"/>
                 </a:solidFill>
-              </a:rPr>
-              <a:t> </a:t>
-            </a:r>
-            <a:r>
-              <a:rPr lang="en-US" dirty="0" err="1">
+                <a:latin typeface="Arial"/>
+              </a:defRPr>
+            </a:pPr>
+            <a:r>
+              <a:t>❌ SAI</a:t>
+            </a:r>
+          </a:p>
+        </p:txBody>
+      </p:sp>
+      <p:pic>
+        <p:nvPicPr>
+          <p:cNvPr id="9" name="Picture 8" descr="ai_bad_posture.jpg"/>
+          <p:cNvPicPr>
+            <a:picLocks noChangeAspect="1"/>
+          </p:cNvPicPr>
+          <p:nvPr/>
+        </p:nvPicPr>
+        <p:blipFill>
+          <a:blip r:embed="rId2"/>
+          <a:stretch>
+            <a:fillRect/>
+          </a:stretch>
+        </p:blipFill>
+        <p:spPr>
+          <a:xfrm>
+            <a:off x="640080" y="2880360"/>
+            <a:ext cx="3108960" cy="1828800"/>
+          </a:xfrm>
+          <a:prstGeom prst="rect">
+            <a:avLst/>
+          </a:prstGeom>
+        </p:spPr>
+      </p:pic>
+      <p:sp>
+        <p:nvSpPr>
+          <p:cNvPr id="10" name="TextBox 9"/>
+          <p:cNvSpPr txBox="1"/>
+          <p:nvPr/>
+        </p:nvSpPr>
+        <p:spPr>
+          <a:xfrm>
+            <a:off x="548640" y="4800600"/>
+            <a:ext cx="3291839" cy="731519"/>
+          </a:xfrm>
+          <a:prstGeom prst="rect">
+            <a:avLst/>
+          </a:prstGeom>
+          <a:noFill/>
+        </p:spPr>
+        <p:txBody>
+          <a:bodyPr wrap="square" lIns="73152" rIns="73152">
+            <a:spAutoFit/>
+          </a:bodyPr>
+          <a:lstStyle/>
+          <a:p>
+            <a:pPr algn="ctr">
+              <a:defRPr sz="1700" b="1">
                 <a:solidFill>
-                  <a:schemeClr val="tx2">
-                    <a:lumMod val="75000"/>
-                    <a:lumOff val="25000"/>
-                  </a:schemeClr>
+                  <a:srgbClr val="0F172A"/>
                 </a:solidFill>
-              </a:rPr>
-              <a:t>lớp</a:t>
-            </a:r>
-            <a:r>
-              <a:rPr lang="en-US" dirty="0">
+                <a:latin typeface="Arial"/>
+              </a:defRPr>
+            </a:pPr>
+            <a:r>
+              <a:t>Hình a: Ngồi sai (Gù lưng)</a:t>
+            </a:r>
+          </a:p>
+        </p:txBody>
+      </p:sp>
+      <p:sp>
+        <p:nvSpPr>
+          <p:cNvPr id="11" name="Rounded Rectangle 10"/>
+          <p:cNvSpPr/>
+          <p:nvPr/>
+        </p:nvSpPr>
+        <p:spPr>
+          <a:xfrm>
+            <a:off x="4206240" y="2331720"/>
+            <a:ext cx="3474720" cy="3291840"/>
+          </a:xfrm>
+          <a:prstGeom prst="roundRect">
+            <a:avLst/>
+          </a:prstGeom>
+          <a:solidFill>
+            <a:srgbClr val="FFFFFF"/>
+          </a:solidFill>
+          <a:ln w="19050">
+            <a:solidFill>
+              <a:srgbClr val="DC2626"/>
+            </a:solidFill>
+          </a:ln>
+        </p:spPr>
+        <p:style>
+          <a:lnRef idx="1">
+            <a:schemeClr val="accent1"/>
+          </a:lnRef>
+          <a:fillRef idx="3">
+            <a:schemeClr val="accent1"/>
+          </a:fillRef>
+          <a:effectRef idx="2">
+            <a:schemeClr val="accent1"/>
+          </a:effectRef>
+          <a:fontRef idx="minor">
+            <a:schemeClr val="lt1"/>
+          </a:fontRef>
+        </p:style>
+        <p:txBody>
+          <a:bodyPr rtlCol="0" anchor="ctr"/>
+          <a:lstStyle/>
+          <a:p>
+            <a:pPr algn="ctr"/>
+            <a:endParaRPr/>
+          </a:p>
+        </p:txBody>
+      </p:sp>
+      <p:sp>
+        <p:nvSpPr>
+          <p:cNvPr id="12" name="Rectangle 11"/>
+          <p:cNvSpPr/>
+          <p:nvPr/>
+        </p:nvSpPr>
+        <p:spPr>
+          <a:xfrm>
+            <a:off x="4206240" y="2331720"/>
+            <a:ext cx="3474720" cy="411480"/>
+          </a:xfrm>
+          <a:prstGeom prst="rect">
+            <a:avLst/>
+          </a:prstGeom>
+          <a:solidFill>
+            <a:srgbClr val="DC2626"/>
+          </a:solidFill>
+          <a:ln>
+            <a:noFill/>
+          </a:ln>
+        </p:spPr>
+        <p:style>
+          <a:lnRef idx="1">
+            <a:schemeClr val="accent1"/>
+          </a:lnRef>
+          <a:fillRef idx="3">
+            <a:schemeClr val="accent1"/>
+          </a:fillRef>
+          <a:effectRef idx="2">
+            <a:schemeClr val="accent1"/>
+          </a:effectRef>
+          <a:fontRef idx="minor">
+            <a:schemeClr val="lt1"/>
+          </a:fontRef>
+        </p:style>
+        <p:txBody>
+          <a:bodyPr rtlCol="0" anchor="ctr"/>
+          <a:lstStyle/>
+          <a:p>
+            <a:pPr algn="ctr"/>
+            <a:endParaRPr/>
+          </a:p>
+        </p:txBody>
+      </p:sp>
+      <p:sp>
+        <p:nvSpPr>
+          <p:cNvPr id="13" name="TextBox 12"/>
+          <p:cNvSpPr txBox="1"/>
+          <p:nvPr/>
+        </p:nvSpPr>
+        <p:spPr>
+          <a:xfrm>
+            <a:off x="4206240" y="2377439"/>
+            <a:ext cx="3474720" cy="365759"/>
+          </a:xfrm>
+          <a:prstGeom prst="rect">
+            <a:avLst/>
+          </a:prstGeom>
+          <a:noFill/>
+        </p:spPr>
+        <p:txBody>
+          <a:bodyPr wrap="square" lIns="73152" rIns="73152">
+            <a:spAutoFit/>
+          </a:bodyPr>
+          <a:lstStyle/>
+          <a:p>
+            <a:pPr algn="ctr">
+              <a:defRPr sz="1800" b="1">
                 <a:solidFill>
-                  <a:schemeClr val="tx2">
-                    <a:lumMod val="75000"/>
-                    <a:lumOff val="25000"/>
-                  </a:schemeClr>
+                  <a:srgbClr val="FFFFFF"/>
                 </a:solidFill>
-              </a:rPr>
-              <a:t> </a:t>
+                <a:latin typeface="Arial"/>
+              </a:defRPr>
+            </a:pPr>
+            <a:r>
+              <a:t>❌ SAI</a:t>
+            </a:r>
+          </a:p>
+        </p:txBody>
+      </p:sp>
+      <p:sp>
+        <p:nvSpPr>
+          <p:cNvPr id="15" name="TextBox 14"/>
+          <p:cNvSpPr txBox="1"/>
+          <p:nvPr/>
+        </p:nvSpPr>
+        <p:spPr>
+          <a:xfrm>
+            <a:off x="4297679" y="4800600"/>
+            <a:ext cx="3291839" cy="731519"/>
+          </a:xfrm>
+          <a:prstGeom prst="rect">
+            <a:avLst/>
+          </a:prstGeom>
+          <a:noFill/>
+        </p:spPr>
+        <p:txBody>
+          <a:bodyPr wrap="square" lIns="73152" rIns="73152">
+            <a:spAutoFit/>
+          </a:bodyPr>
+          <a:lstStyle/>
+          <a:p>
+            <a:pPr algn="ctr">
+              <a:defRPr sz="1700" b="1">
+                <a:solidFill>
+                  <a:srgbClr val="0F172A"/>
+                </a:solidFill>
+                <a:latin typeface="Arial"/>
+              </a:defRPr>
+            </a:pPr>
+            <a:r>
+              <a:t>Hình b: Ngồi sai (Cúi sát mắt)</a:t>
+            </a:r>
+          </a:p>
+        </p:txBody>
+      </p:sp>
+      <p:sp>
+        <p:nvSpPr>
+          <p:cNvPr id="16" name="Rounded Rectangle 15"/>
+          <p:cNvSpPr/>
+          <p:nvPr/>
+        </p:nvSpPr>
+        <p:spPr>
+          <a:xfrm>
+            <a:off x="7955279" y="2331720"/>
+            <a:ext cx="3474720" cy="3291840"/>
+          </a:xfrm>
+          <a:prstGeom prst="roundRect">
+            <a:avLst/>
+          </a:prstGeom>
+          <a:solidFill>
+            <a:srgbClr val="FFFFFF"/>
+          </a:solidFill>
+          <a:ln w="19050">
+            <a:solidFill>
+              <a:srgbClr val="059669"/>
+            </a:solidFill>
+          </a:ln>
+        </p:spPr>
+        <p:style>
+          <a:lnRef idx="1">
+            <a:schemeClr val="accent1"/>
+          </a:lnRef>
+          <a:fillRef idx="3">
+            <a:schemeClr val="accent1"/>
+          </a:fillRef>
+          <a:effectRef idx="2">
+            <a:schemeClr val="accent1"/>
+          </a:effectRef>
+          <a:fontRef idx="minor">
+            <a:schemeClr val="lt1"/>
+          </a:fontRef>
+        </p:style>
+        <p:txBody>
+          <a:bodyPr rtlCol="0" anchor="ctr"/>
+          <a:lstStyle/>
+          <a:p>
+            <a:pPr algn="ctr"/>
+            <a:endParaRPr/>
+          </a:p>
+        </p:txBody>
+      </p:sp>
+      <p:sp>
+        <p:nvSpPr>
+          <p:cNvPr id="17" name="Rectangle 16"/>
+          <p:cNvSpPr/>
+          <p:nvPr/>
+        </p:nvSpPr>
+        <p:spPr>
+          <a:xfrm>
+            <a:off x="7955279" y="2331720"/>
+            <a:ext cx="3474720" cy="411480"/>
+          </a:xfrm>
+          <a:prstGeom prst="rect">
+            <a:avLst/>
+          </a:prstGeom>
+          <a:solidFill>
+            <a:srgbClr val="059669"/>
+          </a:solidFill>
+          <a:ln>
+            <a:noFill/>
+          </a:ln>
+        </p:spPr>
+        <p:style>
+          <a:lnRef idx="1">
+            <a:schemeClr val="accent1"/>
+          </a:lnRef>
+          <a:fillRef idx="3">
+            <a:schemeClr val="accent1"/>
+          </a:fillRef>
+          <a:effectRef idx="2">
+            <a:schemeClr val="accent1"/>
+          </a:effectRef>
+          <a:fontRef idx="minor">
+            <a:schemeClr val="lt1"/>
+          </a:fontRef>
+        </p:style>
+        <p:txBody>
+          <a:bodyPr rtlCol="0" anchor="ctr"/>
+          <a:lstStyle/>
+          <a:p>
+            <a:pPr algn="ctr"/>
+            <a:endParaRPr/>
+          </a:p>
+        </p:txBody>
+      </p:sp>
+      <p:sp>
+        <p:nvSpPr>
+          <p:cNvPr id="18" name="TextBox 17"/>
+          <p:cNvSpPr txBox="1"/>
+          <p:nvPr/>
+        </p:nvSpPr>
+        <p:spPr>
+          <a:xfrm>
+            <a:off x="7955279" y="2377439"/>
+            <a:ext cx="3474720" cy="365759"/>
+          </a:xfrm>
+          <a:prstGeom prst="rect">
+            <a:avLst/>
+          </a:prstGeom>
+          <a:noFill/>
+        </p:spPr>
+        <p:txBody>
+          <a:bodyPr wrap="square" lIns="73152" rIns="73152">
+            <a:spAutoFit/>
+          </a:bodyPr>
+          <a:lstStyle/>
+          <a:p>
+            <a:pPr algn="ctr">
+              <a:defRPr sz="1800" b="1">
+                <a:solidFill>
+                  <a:srgbClr val="FFFFFF"/>
+                </a:solidFill>
+                <a:latin typeface="Arial"/>
+              </a:defRPr>
+            </a:pPr>
+            <a:r>
+              <a:t>✅ ĐÚNG</a:t>
+            </a:r>
+          </a:p>
+        </p:txBody>
+      </p:sp>
+      <p:pic>
+        <p:nvPicPr>
+          <p:cNvPr id="19" name="Picture 18" descr="ai_good_posture.jpg"/>
+          <p:cNvPicPr>
+            <a:picLocks noChangeAspect="1"/>
+          </p:cNvPicPr>
+          <p:nvPr/>
+        </p:nvPicPr>
+        <p:blipFill>
+          <a:blip r:embed="rId3"/>
+          <a:stretch>
+            <a:fillRect/>
+          </a:stretch>
+        </p:blipFill>
+        <p:spPr>
+          <a:xfrm>
+            <a:off x="8138159" y="2880360"/>
+            <a:ext cx="3108960" cy="1828800"/>
+          </a:xfrm>
+          <a:prstGeom prst="rect">
+            <a:avLst/>
+          </a:prstGeom>
+        </p:spPr>
+      </p:pic>
+      <p:sp>
+        <p:nvSpPr>
+          <p:cNvPr id="20" name="TextBox 19"/>
+          <p:cNvSpPr txBox="1"/>
+          <p:nvPr/>
+        </p:nvSpPr>
+        <p:spPr>
+          <a:xfrm>
+            <a:off x="8046719" y="4800600"/>
+            <a:ext cx="3291839" cy="731519"/>
+          </a:xfrm>
+          <a:prstGeom prst="rect">
+            <a:avLst/>
+          </a:prstGeom>
+          <a:noFill/>
+        </p:spPr>
+        <p:txBody>
+          <a:bodyPr wrap="square" lIns="73152" rIns="73152">
+            <a:spAutoFit/>
+          </a:bodyPr>
+          <a:lstStyle/>
+          <a:p>
+            <a:pPr algn="ctr">
+              <a:defRPr sz="1700" b="1">
+                <a:solidFill>
+                  <a:srgbClr val="0F172A"/>
+                </a:solidFill>
+                <a:latin typeface="Arial"/>
+              </a:defRPr>
+            </a:pPr>
+            <a:r>
+              <a:t>Hình c: Ngồi đúng (Thẳng lưng)</a:t>
             </a:r>
           </a:p>
         </p:txBody>
       </p:sp>
     </p:spTree>
-    <p:extLst>
-      <p:ext uri="{BB962C8B-B14F-4D97-AF65-F5344CB8AC3E}">
-        <p14:creationId xmlns:p14="http://schemas.microsoft.com/office/powerpoint/2010/main" val="504304636"/>
-      </p:ext>
-    </p:extLst>
   </p:cSld>
   <p:clrMapOvr>
     <a:masterClrMapping/>
   </p:clrMapOvr>
+  <p:transition spd="med">
+    <p:wipe/>
+  </p:transition>
 </p:sld>
 </file>
 
@@ -3892,92 +4430,20 @@
       </p:grpSpPr>
       <p:sp>
         <p:nvSpPr>
-          <p:cNvPr id="9" name="TextBox 39">
-            <a:extLst>
-              <a:ext uri="{FF2B5EF4-FFF2-40B4-BE49-F238E27FC236}">
-                <a16:creationId xmlns:a16="http://schemas.microsoft.com/office/drawing/2014/main" id="{9F8C78EA-1C6B-6C35-6191-129F37672DA8}"/>
-              </a:ext>
-            </a:extLst>
-          </p:cNvPr>
-          <p:cNvSpPr txBox="1"/>
-          <p:nvPr/>
-        </p:nvSpPr>
-        <p:spPr>
-          <a:xfrm>
-            <a:off x="320174" y="2413337"/>
-            <a:ext cx="11551651" cy="1015663"/>
+          <p:cNvPr id="2" name="Rectangle 1"/>
+          <p:cNvSpPr/>
+          <p:nvPr/>
+        </p:nvSpPr>
+        <p:spPr>
+          <a:xfrm>
+            <a:off x="0" y="1051560"/>
+            <a:ext cx="12188952" cy="4754879"/>
           </a:xfrm>
           <a:prstGeom prst="rect">
             <a:avLst/>
           </a:prstGeom>
-          <a:ln>
-            <a:noFill/>
-          </a:ln>
-        </p:spPr>
-        <p:txBody>
-          <a:bodyPr wrap="square" lIns="0" tIns="0" rIns="0" bIns="0" rtlCol="0" anchor="t">
-            <a:spAutoFit/>
-          </a:bodyPr>
-          <a:lstStyle/>
-          <a:p>
-            <a:pPr algn="ctr"/>
-            <a:r>
-              <a:rPr lang="en-US" sz="6600" dirty="0">
-                <a:solidFill>
-                  <a:schemeClr val="tx2">
-                    <a:lumMod val="75000"/>
-                    <a:lumOff val="25000"/>
-                  </a:schemeClr>
-                </a:solidFill>
-                <a:latin typeface="Monotype Corsiva" panose="03010101010201010101" pitchFamily="66" charset="0"/>
-                <a:ea typeface="Monggirella script"/>
-                <a:cs typeface="Monggirella script"/>
-                <a:sym typeface="Monggirella script"/>
-              </a:rPr>
-              <a:t>Thanks for listening</a:t>
-            </a:r>
-          </a:p>
-        </p:txBody>
-      </p:sp>
-    </p:spTree>
-    <p:extLst>
-      <p:ext uri="{BB962C8B-B14F-4D97-AF65-F5344CB8AC3E}">
-        <p14:creationId xmlns:p14="http://schemas.microsoft.com/office/powerpoint/2010/main" val="1292696729"/>
-      </p:ext>
-    </p:extLst>
-  </p:cSld>
-  <p:clrMapOvr>
-    <a:masterClrMapping/>
-  </p:clrMapOvr>
-</p:sld>
-</file>
-
-<file path=ppt/slides/slide5.xml><?xml version="1.0" encoding="utf-8"?>
-<p:sld xmlns:a="http://schemas.openxmlformats.org/drawingml/2006/main" xmlns:p="http://schemas.openxmlformats.org/presentationml/2006/main" xmlns:r="http://schemas.openxmlformats.org/officeDocument/2006/relationships">
-  <p:cSld>
-    <p:spTree>
-      <p:nvGrpSpPr>
-        <p:cNvPr id="1" name=""/>
-        <p:cNvGrpSpPr/>
-        <p:nvPr/>
-      </p:nvGrpSpPr>
-      <p:grpSpPr/>
-      <p:sp>
-        <p:nvSpPr>
-          <p:cNvPr id="3" name="Rectangle 2"/>
-          <p:cNvSpPr/>
-          <p:nvPr/>
-        </p:nvSpPr>
-        <p:spPr>
-          <a:xfrm>
-            <a:off x="0" y="1051560"/>
-            <a:ext cx="12188952" cy="1645920"/>
-          </a:xfrm>
-          <a:prstGeom prst="rect">
-            <a:avLst/>
-          </a:prstGeom>
           <a:solidFill>
-            <a:srgbClr val="2D7DD2"/>
+            <a:srgbClr val="EBF3FE"/>
           </a:solidFill>
           <a:ln>
             <a:noFill/>
@@ -4002,19 +4468,20 @@
           <a:lstStyle/>
           <a:p>
             <a:pPr algn="ctr"/>
-          </a:p>
-        </p:txBody>
-      </p:sp>
-      <p:sp>
-        <p:nvSpPr>
-          <p:cNvPr id="2" name="Rectangle 1"/>
+            <a:endParaRPr/>
+          </a:p>
+        </p:txBody>
+      </p:sp>
+      <p:sp>
+        <p:nvSpPr>
+          <p:cNvPr id="3" name="Rectangle 2"/>
           <p:cNvSpPr/>
           <p:nvPr/>
         </p:nvSpPr>
         <p:spPr>
           <a:xfrm>
-            <a:off x="0" y="1051560"/>
-            <a:ext cx="12188952" cy="4754879"/>
+            <a:off x="0" y="1097280"/>
+            <a:ext cx="12188952" cy="411479"/>
           </a:xfrm>
           <a:prstGeom prst="rect">
             <a:avLst/>
@@ -4045,185 +4512,7 @@
           <a:lstStyle/>
           <a:p>
             <a:pPr algn="ctr"/>
-          </a:p>
-        </p:txBody>
-      </p:sp>
-      <p:sp>
-        <p:nvSpPr>
-          <p:cNvPr id="4" name="TextBox 3"/>
-          <p:cNvSpPr txBox="1"/>
-          <p:nvPr/>
-        </p:nvSpPr>
-        <p:spPr>
-          <a:xfrm>
-            <a:off x="731520" y="1828800"/>
-            <a:ext cx="6858000" cy="1371600"/>
-          </a:xfrm>
-          <a:prstGeom prst="rect">
-            <a:avLst/>
-          </a:prstGeom>
-          <a:noFill/>
-        </p:spPr>
-        <p:txBody>
-          <a:bodyPr wrap="square" lIns="73152" rIns="73152">
-            <a:spAutoFit/>
-          </a:bodyPr>
-          <a:lstStyle/>
-          <a:p>
-            <a:pPr algn="l">
-              <a:defRPr sz="3400" b="1">
-                <a:solidFill>
-                  <a:srgbClr val="FFFFFF"/>
-                </a:solidFill>
-                <a:latin typeface="Arial"/>
-              </a:defRPr>
-            </a:pPr>
-            <a:r>
-              <a:t>Em ngồi máy tính an toàn 🪑</a:t>
-            </a:r>
-          </a:p>
-        </p:txBody>
-      </p:sp>
-      <p:sp>
-        <p:nvSpPr>
-          <p:cNvPr id="5" name="TextBox 4"/>
-          <p:cNvSpPr txBox="1"/>
-          <p:nvPr/>
-        </p:nvSpPr>
-        <p:spPr>
-          <a:xfrm>
-            <a:off x="731520" y="3474720"/>
-            <a:ext cx="6858000" cy="731519"/>
-          </a:xfrm>
-          <a:prstGeom prst="rect">
-            <a:avLst/>
-          </a:prstGeom>
-          <a:noFill/>
-        </p:spPr>
-        <p:txBody>
-          <a:bodyPr wrap="square" lIns="73152" rIns="73152">
-            <a:spAutoFit/>
-          </a:bodyPr>
-          <a:lstStyle/>
-          <a:p>
-            <a:pPr algn="l">
-              <a:defRPr sz="2000" b="0">
-                <a:solidFill>
-                  <a:srgbClr val="FFFFFF"/>
-                </a:solidFill>
-                <a:latin typeface="Arial"/>
-              </a:defRPr>
-            </a:pPr>
-            <a:r>
-              <a:t>Tin học • Tiền Tiểu học • Tiết 3</a:t>
-            </a:r>
-          </a:p>
-        </p:txBody>
-      </p:sp>
-    </p:spTree>
-  </p:cSld>
-  <p:clrMapOvr>
-    <a:masterClrMapping/>
-  </p:clrMapOvr>
-  <p:transition spd="med">
-    <p:fade/>
-  </p:transition>
-</p:sld>
-</file>
-
-<file path=ppt/slides/slide6.xml><?xml version="1.0" encoding="utf-8"?>
-<p:sld xmlns:a="http://schemas.openxmlformats.org/drawingml/2006/main" xmlns:p="http://schemas.openxmlformats.org/presentationml/2006/main" xmlns:r="http://schemas.openxmlformats.org/officeDocument/2006/relationships">
-  <p:cSld>
-    <p:spTree>
-      <p:nvGrpSpPr>
-        <p:cNvPr id="1" name=""/>
-        <p:cNvGrpSpPr/>
-        <p:nvPr/>
-      </p:nvGrpSpPr>
-      <p:grpSpPr/>
-      <p:sp>
-        <p:nvSpPr>
-          <p:cNvPr id="2" name="Rectangle 1"/>
-          <p:cNvSpPr/>
-          <p:nvPr/>
-        </p:nvSpPr>
-        <p:spPr>
-          <a:xfrm>
-            <a:off x="0" y="1051560"/>
-            <a:ext cx="12188952" cy="4754879"/>
-          </a:xfrm>
-          <a:prstGeom prst="rect">
-            <a:avLst/>
-          </a:prstGeom>
-          <a:solidFill>
-            <a:srgbClr val="EBF3FE"/>
-          </a:solidFill>
-          <a:ln>
-            <a:noFill/>
-          </a:ln>
-        </p:spPr>
-        <p:style>
-          <a:lnRef idx="1">
-            <a:schemeClr val="accent1"/>
-          </a:lnRef>
-          <a:fillRef idx="3">
-            <a:schemeClr val="accent1"/>
-          </a:fillRef>
-          <a:effectRef idx="2">
-            <a:schemeClr val="accent1"/>
-          </a:effectRef>
-          <a:fontRef idx="minor">
-            <a:schemeClr val="lt1"/>
-          </a:fontRef>
-        </p:style>
-        <p:txBody>
-          <a:bodyPr rtlCol="0" anchor="ctr"/>
-          <a:lstStyle/>
-          <a:p>
-            <a:pPr algn="ctr"/>
-          </a:p>
-        </p:txBody>
-      </p:sp>
-      <p:sp>
-        <p:nvSpPr>
-          <p:cNvPr id="3" name="Rectangle 2"/>
-          <p:cNvSpPr/>
-          <p:nvPr/>
-        </p:nvSpPr>
-        <p:spPr>
-          <a:xfrm>
-            <a:off x="0" y="1097280"/>
-            <a:ext cx="12188952" cy="411479"/>
-          </a:xfrm>
-          <a:prstGeom prst="rect">
-            <a:avLst/>
-          </a:prstGeom>
-          <a:solidFill>
-            <a:srgbClr val="1B4F9B"/>
-          </a:solidFill>
-          <a:ln>
-            <a:noFill/>
-          </a:ln>
-        </p:spPr>
-        <p:style>
-          <a:lnRef idx="1">
-            <a:schemeClr val="accent1"/>
-          </a:lnRef>
-          <a:fillRef idx="3">
-            <a:schemeClr val="accent1"/>
-          </a:fillRef>
-          <a:effectRef idx="2">
-            <a:schemeClr val="accent1"/>
-          </a:effectRef>
-          <a:fontRef idx="minor">
-            <a:schemeClr val="lt1"/>
-          </a:fontRef>
-        </p:style>
-        <p:txBody>
-          <a:bodyPr rtlCol="0" anchor="ctr"/>
-          <a:lstStyle/>
-          <a:p>
-            <a:pPr algn="ctr"/>
+            <a:endParaRPr/>
           </a:p>
         </p:txBody>
       </p:sp>
@@ -4258,7 +4547,7 @@
               </a:defRPr>
             </a:pPr>
             <a:r>
-              <a:t>  TIỀN TIỂU HỌC • KHÁM PHÁ BÀI HỌC</a:t>
+              <a:t>  TIỀN TIỂU HỌC • QUY CHUẨN TRỰC QUAN</a:t>
             </a:r>
           </a:p>
         </p:txBody>
@@ -4294,7 +4583,7 @@
               </a:defRPr>
             </a:pPr>
             <a:r>
-              <a:t>Bạn nào ngồi học đúng tư thế?</a:t>
+              <a:t>4 Quy tắc ngồi máy tính an toàn</a:t>
             </a:r>
           </a:p>
         </p:txBody>
@@ -4307,8 +4596,8 @@
         </p:nvSpPr>
         <p:spPr>
           <a:xfrm>
-            <a:off x="457200" y="2331720"/>
-            <a:ext cx="3474720" cy="3291840"/>
+            <a:off x="457200" y="2286000"/>
+            <a:ext cx="5669280" cy="640080"/>
           </a:xfrm>
           <a:prstGeom prst="roundRect">
             <a:avLst/>
@@ -4318,7 +4607,7 @@
           </a:solidFill>
           <a:ln w="19050">
             <a:solidFill>
-              <a:srgbClr val="DC2626"/>
+              <a:srgbClr val="EA580C"/>
             </a:solidFill>
           </a:ln>
         </p:spPr>
@@ -4341,6 +4630,7 @@
           <a:lstStyle/>
           <a:p>
             <a:pPr algn="ctr"/>
+            <a:endParaRPr/>
           </a:p>
         </p:txBody>
       </p:sp>
@@ -4352,14 +4642,14 @@
         </p:nvSpPr>
         <p:spPr>
           <a:xfrm>
-            <a:off x="457200" y="2331720"/>
-            <a:ext cx="3474720" cy="411480"/>
+            <a:off x="457200" y="2286000"/>
+            <a:ext cx="182880" cy="640080"/>
           </a:xfrm>
           <a:prstGeom prst="rect">
             <a:avLst/>
           </a:prstGeom>
           <a:solidFill>
-            <a:srgbClr val="DC2626"/>
+            <a:srgbClr val="EA580C"/>
           </a:solidFill>
           <a:ln>
             <a:noFill/>
@@ -4384,6 +4674,7 @@
           <a:lstStyle/>
           <a:p>
             <a:pPr algn="ctr"/>
+            <a:endParaRPr/>
           </a:p>
         </p:txBody>
       </p:sp>
@@ -4395,8 +4686,8 @@
         </p:nvSpPr>
         <p:spPr>
           <a:xfrm>
-            <a:off x="457200" y="2377439"/>
-            <a:ext cx="3474720" cy="365759"/>
+            <a:off x="822960" y="2395728"/>
+            <a:ext cx="5120640" cy="420623"/>
           </a:xfrm>
           <a:prstGeom prst="rect">
             <a:avLst/>
@@ -4409,67 +4700,7 @@
           </a:bodyPr>
           <a:lstStyle/>
           <a:p>
-            <a:pPr algn="ctr">
-              <a:defRPr sz="1800" b="1">
-                <a:solidFill>
-                  <a:srgbClr val="FFFFFF"/>
-                </a:solidFill>
-                <a:latin typeface="Arial"/>
-              </a:defRPr>
-            </a:pPr>
-            <a:r>
-              <a:t>❌ SAI</a:t>
-            </a:r>
-          </a:p>
-        </p:txBody>
-      </p:sp>
-      <p:pic>
-        <p:nvPicPr>
-          <p:cNvPr id="9" name="Picture 8" descr="ai_bad_posture.jpg"/>
-          <p:cNvPicPr>
-            <a:picLocks noChangeAspect="1"/>
-          </p:cNvPicPr>
-          <p:nvPr/>
-        </p:nvPicPr>
-        <p:blipFill>
-          <a:blip r:embed="rId2"/>
-          <a:stretch>
-            <a:fillRect/>
-          </a:stretch>
-        </p:blipFill>
-        <p:spPr>
-          <a:xfrm>
-            <a:off x="640080" y="2880360"/>
-            <a:ext cx="3108960" cy="1828800"/>
-          </a:xfrm>
-          <a:prstGeom prst="rect">
-            <a:avLst/>
-          </a:prstGeom>
-        </p:spPr>
-      </p:pic>
-      <p:sp>
-        <p:nvSpPr>
-          <p:cNvPr id="10" name="TextBox 9"/>
-          <p:cNvSpPr txBox="1"/>
-          <p:nvPr/>
-        </p:nvSpPr>
-        <p:spPr>
-          <a:xfrm>
-            <a:off x="548640" y="4800600"/>
-            <a:ext cx="3291839" cy="731519"/>
-          </a:xfrm>
-          <a:prstGeom prst="rect">
-            <a:avLst/>
-          </a:prstGeom>
-          <a:noFill/>
-        </p:spPr>
-        <p:txBody>
-          <a:bodyPr wrap="square" lIns="73152" rIns="73152">
-            <a:spAutoFit/>
-          </a:bodyPr>
-          <a:lstStyle/>
-          <a:p>
-            <a:pPr algn="ctr">
+            <a:pPr algn="l">
               <a:defRPr sz="1700" b="1">
                 <a:solidFill>
                   <a:srgbClr val="0F172A"/>
@@ -4478,21 +4709,21 @@
               </a:defRPr>
             </a:pPr>
             <a:r>
-              <a:t>Hình a: Ngồi sai (Gù lưng)</a:t>
-            </a:r>
-          </a:p>
-        </p:txBody>
-      </p:sp>
-      <p:sp>
-        <p:nvSpPr>
-          <p:cNvPr id="11" name="Rounded Rectangle 10"/>
+              <a:t>1. Ngồi thẳng lưng, tựa nhẹ vào ghế</a:t>
+            </a:r>
+          </a:p>
+        </p:txBody>
+      </p:sp>
+      <p:sp>
+        <p:nvSpPr>
+          <p:cNvPr id="9" name="Rounded Rectangle 8"/>
           <p:cNvSpPr/>
           <p:nvPr/>
         </p:nvSpPr>
         <p:spPr>
           <a:xfrm>
-            <a:off x="4206240" y="2331720"/>
-            <a:ext cx="3474720" cy="3291840"/>
+            <a:off x="457200" y="3054096"/>
+            <a:ext cx="5669280" cy="640080"/>
           </a:xfrm>
           <a:prstGeom prst="roundRect">
             <a:avLst/>
@@ -4502,7 +4733,7 @@
           </a:solidFill>
           <a:ln w="19050">
             <a:solidFill>
-              <a:srgbClr val="DC2626"/>
+              <a:srgbClr val="2563EB"/>
             </a:solidFill>
           </a:ln>
         </p:spPr>
@@ -4525,25 +4756,26 @@
           <a:lstStyle/>
           <a:p>
             <a:pPr algn="ctr"/>
-          </a:p>
-        </p:txBody>
-      </p:sp>
-      <p:sp>
-        <p:nvSpPr>
-          <p:cNvPr id="12" name="Rectangle 11"/>
+            <a:endParaRPr/>
+          </a:p>
+        </p:txBody>
+      </p:sp>
+      <p:sp>
+        <p:nvSpPr>
+          <p:cNvPr id="10" name="Rectangle 9"/>
           <p:cNvSpPr/>
           <p:nvPr/>
         </p:nvSpPr>
         <p:spPr>
           <a:xfrm>
-            <a:off x="4206240" y="2331720"/>
-            <a:ext cx="3474720" cy="411480"/>
+            <a:off x="457200" y="3054096"/>
+            <a:ext cx="182880" cy="640080"/>
           </a:xfrm>
           <a:prstGeom prst="rect">
             <a:avLst/>
           </a:prstGeom>
           <a:solidFill>
-            <a:srgbClr val="DC2626"/>
+            <a:srgbClr val="2563EB"/>
           </a:solidFill>
           <a:ln>
             <a:noFill/>
@@ -4568,19 +4800,20 @@
           <a:lstStyle/>
           <a:p>
             <a:pPr algn="ctr"/>
-          </a:p>
-        </p:txBody>
-      </p:sp>
-      <p:sp>
-        <p:nvSpPr>
-          <p:cNvPr id="13" name="TextBox 12"/>
+            <a:endParaRPr/>
+          </a:p>
+        </p:txBody>
+      </p:sp>
+      <p:sp>
+        <p:nvSpPr>
+          <p:cNvPr id="11" name="TextBox 10"/>
           <p:cNvSpPr txBox="1"/>
           <p:nvPr/>
         </p:nvSpPr>
         <p:spPr>
           <a:xfrm>
-            <a:off x="4206240" y="2377439"/>
-            <a:ext cx="3474720" cy="365759"/>
+            <a:off x="822960" y="3163824"/>
+            <a:ext cx="5120640" cy="420623"/>
           </a:xfrm>
           <a:prstGeom prst="rect">
             <a:avLst/>
@@ -4593,67 +4826,7 @@
           </a:bodyPr>
           <a:lstStyle/>
           <a:p>
-            <a:pPr algn="ctr">
-              <a:defRPr sz="1800" b="1">
-                <a:solidFill>
-                  <a:srgbClr val="FFFFFF"/>
-                </a:solidFill>
-                <a:latin typeface="Arial"/>
-              </a:defRPr>
-            </a:pPr>
-            <a:r>
-              <a:t>❌ SAI</a:t>
-            </a:r>
-          </a:p>
-        </p:txBody>
-      </p:sp>
-      <p:pic>
-        <p:nvPicPr>
-          <p:cNvPr id="14" name="Picture 13" descr="learn1_card2.png"/>
-          <p:cNvPicPr>
-            <a:picLocks noChangeAspect="1"/>
-          </p:cNvPicPr>
-          <p:nvPr/>
-        </p:nvPicPr>
-        <p:blipFill>
-          <a:blip r:embed="rId3"/>
-          <a:stretch>
-            <a:fillRect/>
-          </a:stretch>
-        </p:blipFill>
-        <p:spPr>
-          <a:xfrm>
-            <a:off x="4389120" y="2880360"/>
-            <a:ext cx="3108960" cy="1828800"/>
-          </a:xfrm>
-          <a:prstGeom prst="rect">
-            <a:avLst/>
-          </a:prstGeom>
-        </p:spPr>
-      </p:pic>
-      <p:sp>
-        <p:nvSpPr>
-          <p:cNvPr id="15" name="TextBox 14"/>
-          <p:cNvSpPr txBox="1"/>
-          <p:nvPr/>
-        </p:nvSpPr>
-        <p:spPr>
-          <a:xfrm>
-            <a:off x="4297679" y="4800600"/>
-            <a:ext cx="3291839" cy="731519"/>
-          </a:xfrm>
-          <a:prstGeom prst="rect">
-            <a:avLst/>
-          </a:prstGeom>
-          <a:noFill/>
-        </p:spPr>
-        <p:txBody>
-          <a:bodyPr wrap="square" lIns="73152" rIns="73152">
-            <a:spAutoFit/>
-          </a:bodyPr>
-          <a:lstStyle/>
-          <a:p>
-            <a:pPr algn="ctr">
+            <a:pPr algn="l">
               <a:defRPr sz="1700" b="1">
                 <a:solidFill>
                   <a:srgbClr val="0F172A"/>
@@ -4662,21 +4835,21 @@
               </a:defRPr>
             </a:pPr>
             <a:r>
-              <a:t>Hình b: Ngồi sai (Cúi sát mắt)</a:t>
-            </a:r>
-          </a:p>
-        </p:txBody>
-      </p:sp>
-      <p:sp>
-        <p:nvSpPr>
-          <p:cNvPr id="16" name="Rounded Rectangle 15"/>
+              <a:t>2. Hai bàn chân đặt bằng phẳng trên sàn</a:t>
+            </a:r>
+          </a:p>
+        </p:txBody>
+      </p:sp>
+      <p:sp>
+        <p:nvSpPr>
+          <p:cNvPr id="12" name="Rounded Rectangle 11"/>
           <p:cNvSpPr/>
           <p:nvPr/>
         </p:nvSpPr>
         <p:spPr>
           <a:xfrm>
-            <a:off x="7955279" y="2331720"/>
-            <a:ext cx="3474720" cy="3291840"/>
+            <a:off x="457200" y="3822191"/>
+            <a:ext cx="5669280" cy="640080"/>
           </a:xfrm>
           <a:prstGeom prst="roundRect">
             <a:avLst/>
@@ -4709,19 +4882,20 @@
           <a:lstStyle/>
           <a:p>
             <a:pPr algn="ctr"/>
-          </a:p>
-        </p:txBody>
-      </p:sp>
-      <p:sp>
-        <p:nvSpPr>
-          <p:cNvPr id="17" name="Rectangle 16"/>
+            <a:endParaRPr/>
+          </a:p>
+        </p:txBody>
+      </p:sp>
+      <p:sp>
+        <p:nvSpPr>
+          <p:cNvPr id="13" name="Rectangle 12"/>
           <p:cNvSpPr/>
           <p:nvPr/>
         </p:nvSpPr>
         <p:spPr>
           <a:xfrm>
-            <a:off x="7955279" y="2331720"/>
-            <a:ext cx="3474720" cy="411480"/>
+            <a:off x="457200" y="3822191"/>
+            <a:ext cx="182880" cy="640080"/>
           </a:xfrm>
           <a:prstGeom prst="rect">
             <a:avLst/>
@@ -4752,381 +4926,19 @@
           <a:lstStyle/>
           <a:p>
             <a:pPr algn="ctr"/>
-          </a:p>
-        </p:txBody>
-      </p:sp>
-      <p:sp>
-        <p:nvSpPr>
-          <p:cNvPr id="18" name="TextBox 17"/>
+            <a:endParaRPr/>
+          </a:p>
+        </p:txBody>
+      </p:sp>
+      <p:sp>
+        <p:nvSpPr>
+          <p:cNvPr id="14" name="TextBox 13"/>
           <p:cNvSpPr txBox="1"/>
           <p:nvPr/>
         </p:nvSpPr>
         <p:spPr>
           <a:xfrm>
-            <a:off x="7955279" y="2377439"/>
-            <a:ext cx="3474720" cy="365759"/>
-          </a:xfrm>
-          <a:prstGeom prst="rect">
-            <a:avLst/>
-          </a:prstGeom>
-          <a:noFill/>
-        </p:spPr>
-        <p:txBody>
-          <a:bodyPr wrap="square" lIns="73152" rIns="73152">
-            <a:spAutoFit/>
-          </a:bodyPr>
-          <a:lstStyle/>
-          <a:p>
-            <a:pPr algn="ctr">
-              <a:defRPr sz="1800" b="1">
-                <a:solidFill>
-                  <a:srgbClr val="FFFFFF"/>
-                </a:solidFill>
-                <a:latin typeface="Arial"/>
-              </a:defRPr>
-            </a:pPr>
-            <a:r>
-              <a:t>✅ ĐÚNG</a:t>
-            </a:r>
-          </a:p>
-        </p:txBody>
-      </p:sp>
-      <p:pic>
-        <p:nvPicPr>
-          <p:cNvPr id="19" name="Picture 18" descr="ai_good_posture.jpg"/>
-          <p:cNvPicPr>
-            <a:picLocks noChangeAspect="1"/>
-          </p:cNvPicPr>
-          <p:nvPr/>
-        </p:nvPicPr>
-        <p:blipFill>
-          <a:blip r:embed="rId4"/>
-          <a:stretch>
-            <a:fillRect/>
-          </a:stretch>
-        </p:blipFill>
-        <p:spPr>
-          <a:xfrm>
-            <a:off x="8138159" y="2880360"/>
-            <a:ext cx="3108960" cy="1828800"/>
-          </a:xfrm>
-          <a:prstGeom prst="rect">
-            <a:avLst/>
-          </a:prstGeom>
-        </p:spPr>
-      </p:pic>
-      <p:sp>
-        <p:nvSpPr>
-          <p:cNvPr id="20" name="TextBox 19"/>
-          <p:cNvSpPr txBox="1"/>
-          <p:nvPr/>
-        </p:nvSpPr>
-        <p:spPr>
-          <a:xfrm>
-            <a:off x="8046719" y="4800600"/>
-            <a:ext cx="3291839" cy="731519"/>
-          </a:xfrm>
-          <a:prstGeom prst="rect">
-            <a:avLst/>
-          </a:prstGeom>
-          <a:noFill/>
-        </p:spPr>
-        <p:txBody>
-          <a:bodyPr wrap="square" lIns="73152" rIns="73152">
-            <a:spAutoFit/>
-          </a:bodyPr>
-          <a:lstStyle/>
-          <a:p>
-            <a:pPr algn="ctr">
-              <a:defRPr sz="1700" b="1">
-                <a:solidFill>
-                  <a:srgbClr val="0F172A"/>
-                </a:solidFill>
-                <a:latin typeface="Arial"/>
-              </a:defRPr>
-            </a:pPr>
-            <a:r>
-              <a:t>Hình c: Ngồi đúng (Thẳng lưng)</a:t>
-            </a:r>
-          </a:p>
-        </p:txBody>
-      </p:sp>
-    </p:spTree>
-  </p:cSld>
-  <p:clrMapOvr>
-    <a:masterClrMapping/>
-  </p:clrMapOvr>
-  <p:transition spd="med">
-    <p:wipe/>
-  </p:transition>
-</p:sld>
-</file>
-
-<file path=ppt/slides/slide7.xml><?xml version="1.0" encoding="utf-8"?>
-<p:sld xmlns:a="http://schemas.openxmlformats.org/drawingml/2006/main" xmlns:p="http://schemas.openxmlformats.org/presentationml/2006/main" xmlns:r="http://schemas.openxmlformats.org/officeDocument/2006/relationships">
-  <p:cSld>
-    <p:spTree>
-      <p:nvGrpSpPr>
-        <p:cNvPr id="1" name=""/>
-        <p:cNvGrpSpPr/>
-        <p:nvPr/>
-      </p:nvGrpSpPr>
-      <p:grpSpPr/>
-      <p:sp>
-        <p:nvSpPr>
-          <p:cNvPr id="2" name="Rectangle 1"/>
-          <p:cNvSpPr/>
-          <p:nvPr/>
-        </p:nvSpPr>
-        <p:spPr>
-          <a:xfrm>
-            <a:off x="0" y="1051560"/>
-            <a:ext cx="12188952" cy="4754879"/>
-          </a:xfrm>
-          <a:prstGeom prst="rect">
-            <a:avLst/>
-          </a:prstGeom>
-          <a:solidFill>
-            <a:srgbClr val="EBF3FE"/>
-          </a:solidFill>
-          <a:ln>
-            <a:noFill/>
-          </a:ln>
-        </p:spPr>
-        <p:style>
-          <a:lnRef idx="1">
-            <a:schemeClr val="accent1"/>
-          </a:lnRef>
-          <a:fillRef idx="3">
-            <a:schemeClr val="accent1"/>
-          </a:fillRef>
-          <a:effectRef idx="2">
-            <a:schemeClr val="accent1"/>
-          </a:effectRef>
-          <a:fontRef idx="minor">
-            <a:schemeClr val="lt1"/>
-          </a:fontRef>
-        </p:style>
-        <p:txBody>
-          <a:bodyPr rtlCol="0" anchor="ctr"/>
-          <a:lstStyle/>
-          <a:p>
-            <a:pPr algn="ctr"/>
-          </a:p>
-        </p:txBody>
-      </p:sp>
-      <p:sp>
-        <p:nvSpPr>
-          <p:cNvPr id="3" name="Rectangle 2"/>
-          <p:cNvSpPr/>
-          <p:nvPr/>
-        </p:nvSpPr>
-        <p:spPr>
-          <a:xfrm>
-            <a:off x="0" y="1097280"/>
-            <a:ext cx="12188952" cy="411479"/>
-          </a:xfrm>
-          <a:prstGeom prst="rect">
-            <a:avLst/>
-          </a:prstGeom>
-          <a:solidFill>
-            <a:srgbClr val="1B4F9B"/>
-          </a:solidFill>
-          <a:ln>
-            <a:noFill/>
-          </a:ln>
-        </p:spPr>
-        <p:style>
-          <a:lnRef idx="1">
-            <a:schemeClr val="accent1"/>
-          </a:lnRef>
-          <a:fillRef idx="3">
-            <a:schemeClr val="accent1"/>
-          </a:fillRef>
-          <a:effectRef idx="2">
-            <a:schemeClr val="accent1"/>
-          </a:effectRef>
-          <a:fontRef idx="minor">
-            <a:schemeClr val="lt1"/>
-          </a:fontRef>
-        </p:style>
-        <p:txBody>
-          <a:bodyPr rtlCol="0" anchor="ctr"/>
-          <a:lstStyle/>
-          <a:p>
-            <a:pPr algn="ctr"/>
-          </a:p>
-        </p:txBody>
-      </p:sp>
-      <p:sp>
-        <p:nvSpPr>
-          <p:cNvPr id="4" name="TextBox 3"/>
-          <p:cNvSpPr txBox="1"/>
-          <p:nvPr/>
-        </p:nvSpPr>
-        <p:spPr>
-          <a:xfrm>
-            <a:off x="274320" y="1124712"/>
-            <a:ext cx="11640312" cy="365759"/>
-          </a:xfrm>
-          <a:prstGeom prst="rect">
-            <a:avLst/>
-          </a:prstGeom>
-          <a:noFill/>
-        </p:spPr>
-        <p:txBody>
-          <a:bodyPr wrap="square" lIns="73152" rIns="73152">
-            <a:spAutoFit/>
-          </a:bodyPr>
-          <a:lstStyle/>
-          <a:p>
-            <a:pPr algn="l">
-              <a:defRPr sz="1300" b="1">
-                <a:solidFill>
-                  <a:srgbClr val="FFFFFF"/>
-                </a:solidFill>
-                <a:latin typeface="Arial"/>
-              </a:defRPr>
-            </a:pPr>
-            <a:r>
-              <a:t>  TIỀN TIỂU HỌC • QUY CHUẨN TRỰC QUAN</a:t>
-            </a:r>
-          </a:p>
-        </p:txBody>
-      </p:sp>
-      <p:sp>
-        <p:nvSpPr>
-          <p:cNvPr id="5" name="TextBox 4"/>
-          <p:cNvSpPr txBox="1"/>
-          <p:nvPr/>
-        </p:nvSpPr>
-        <p:spPr>
-          <a:xfrm>
-            <a:off x="457200" y="1600200"/>
-            <a:ext cx="11274552" cy="594359"/>
-          </a:xfrm>
-          <a:prstGeom prst="rect">
-            <a:avLst/>
-          </a:prstGeom>
-          <a:noFill/>
-        </p:spPr>
-        <p:txBody>
-          <a:bodyPr wrap="square" lIns="73152" rIns="73152">
-            <a:spAutoFit/>
-          </a:bodyPr>
-          <a:lstStyle/>
-          <a:p>
-            <a:pPr algn="l">
-              <a:defRPr sz="2600" b="1">
-                <a:solidFill>
-                  <a:srgbClr val="1A2744"/>
-                </a:solidFill>
-                <a:latin typeface="Arial"/>
-              </a:defRPr>
-            </a:pPr>
-            <a:r>
-              <a:t>4 Quy tắc ngồi máy tính an toàn</a:t>
-            </a:r>
-          </a:p>
-        </p:txBody>
-      </p:sp>
-      <p:sp>
-        <p:nvSpPr>
-          <p:cNvPr id="6" name="Rounded Rectangle 5"/>
-          <p:cNvSpPr/>
-          <p:nvPr/>
-        </p:nvSpPr>
-        <p:spPr>
-          <a:xfrm>
-            <a:off x="457200" y="2286000"/>
-            <a:ext cx="5669280" cy="640080"/>
-          </a:xfrm>
-          <a:prstGeom prst="roundRect">
-            <a:avLst/>
-          </a:prstGeom>
-          <a:solidFill>
-            <a:srgbClr val="FFFFFF"/>
-          </a:solidFill>
-          <a:ln w="19050">
-            <a:solidFill>
-              <a:srgbClr val="EA580C"/>
-            </a:solidFill>
-          </a:ln>
-        </p:spPr>
-        <p:style>
-          <a:lnRef idx="1">
-            <a:schemeClr val="accent1"/>
-          </a:lnRef>
-          <a:fillRef idx="3">
-            <a:schemeClr val="accent1"/>
-          </a:fillRef>
-          <a:effectRef idx="2">
-            <a:schemeClr val="accent1"/>
-          </a:effectRef>
-          <a:fontRef idx="minor">
-            <a:schemeClr val="lt1"/>
-          </a:fontRef>
-        </p:style>
-        <p:txBody>
-          <a:bodyPr rtlCol="0" anchor="ctr"/>
-          <a:lstStyle/>
-          <a:p>
-            <a:pPr algn="ctr"/>
-          </a:p>
-        </p:txBody>
-      </p:sp>
-      <p:sp>
-        <p:nvSpPr>
-          <p:cNvPr id="7" name="Rectangle 6"/>
-          <p:cNvSpPr/>
-          <p:nvPr/>
-        </p:nvSpPr>
-        <p:spPr>
-          <a:xfrm>
-            <a:off x="457200" y="2286000"/>
-            <a:ext cx="182880" cy="640080"/>
-          </a:xfrm>
-          <a:prstGeom prst="rect">
-            <a:avLst/>
-          </a:prstGeom>
-          <a:solidFill>
-            <a:srgbClr val="EA580C"/>
-          </a:solidFill>
-          <a:ln>
-            <a:noFill/>
-          </a:ln>
-        </p:spPr>
-        <p:style>
-          <a:lnRef idx="1">
-            <a:schemeClr val="accent1"/>
-          </a:lnRef>
-          <a:fillRef idx="3">
-            <a:schemeClr val="accent1"/>
-          </a:fillRef>
-          <a:effectRef idx="2">
-            <a:schemeClr val="accent1"/>
-          </a:effectRef>
-          <a:fontRef idx="minor">
-            <a:schemeClr val="lt1"/>
-          </a:fontRef>
-        </p:style>
-        <p:txBody>
-          <a:bodyPr rtlCol="0" anchor="ctr"/>
-          <a:lstStyle/>
-          <a:p>
-            <a:pPr algn="ctr"/>
-          </a:p>
-        </p:txBody>
-      </p:sp>
-      <p:sp>
-        <p:nvSpPr>
-          <p:cNvPr id="8" name="TextBox 7"/>
-          <p:cNvSpPr txBox="1"/>
-          <p:nvPr/>
-        </p:nvSpPr>
-        <p:spPr>
-          <a:xfrm>
-            <a:off x="822960" y="2395728"/>
+            <a:off x="822960" y="3931920"/>
             <a:ext cx="5120640" cy="420623"/>
           </a:xfrm>
           <a:prstGeom prst="rect">
@@ -5149,254 +4961,6 @@
               </a:defRPr>
             </a:pPr>
             <a:r>
-              <a:t>1. Ngồi thẳng lưng, tựa nhẹ vào ghế</a:t>
-            </a:r>
-          </a:p>
-        </p:txBody>
-      </p:sp>
-      <p:sp>
-        <p:nvSpPr>
-          <p:cNvPr id="9" name="Rounded Rectangle 8"/>
-          <p:cNvSpPr/>
-          <p:nvPr/>
-        </p:nvSpPr>
-        <p:spPr>
-          <a:xfrm>
-            <a:off x="457200" y="3054096"/>
-            <a:ext cx="5669280" cy="640080"/>
-          </a:xfrm>
-          <a:prstGeom prst="roundRect">
-            <a:avLst/>
-          </a:prstGeom>
-          <a:solidFill>
-            <a:srgbClr val="FFFFFF"/>
-          </a:solidFill>
-          <a:ln w="19050">
-            <a:solidFill>
-              <a:srgbClr val="2563EB"/>
-            </a:solidFill>
-          </a:ln>
-        </p:spPr>
-        <p:style>
-          <a:lnRef idx="1">
-            <a:schemeClr val="accent1"/>
-          </a:lnRef>
-          <a:fillRef idx="3">
-            <a:schemeClr val="accent1"/>
-          </a:fillRef>
-          <a:effectRef idx="2">
-            <a:schemeClr val="accent1"/>
-          </a:effectRef>
-          <a:fontRef idx="minor">
-            <a:schemeClr val="lt1"/>
-          </a:fontRef>
-        </p:style>
-        <p:txBody>
-          <a:bodyPr rtlCol="0" anchor="ctr"/>
-          <a:lstStyle/>
-          <a:p>
-            <a:pPr algn="ctr"/>
-          </a:p>
-        </p:txBody>
-      </p:sp>
-      <p:sp>
-        <p:nvSpPr>
-          <p:cNvPr id="10" name="Rectangle 9"/>
-          <p:cNvSpPr/>
-          <p:nvPr/>
-        </p:nvSpPr>
-        <p:spPr>
-          <a:xfrm>
-            <a:off x="457200" y="3054096"/>
-            <a:ext cx="182880" cy="640080"/>
-          </a:xfrm>
-          <a:prstGeom prst="rect">
-            <a:avLst/>
-          </a:prstGeom>
-          <a:solidFill>
-            <a:srgbClr val="2563EB"/>
-          </a:solidFill>
-          <a:ln>
-            <a:noFill/>
-          </a:ln>
-        </p:spPr>
-        <p:style>
-          <a:lnRef idx="1">
-            <a:schemeClr val="accent1"/>
-          </a:lnRef>
-          <a:fillRef idx="3">
-            <a:schemeClr val="accent1"/>
-          </a:fillRef>
-          <a:effectRef idx="2">
-            <a:schemeClr val="accent1"/>
-          </a:effectRef>
-          <a:fontRef idx="minor">
-            <a:schemeClr val="lt1"/>
-          </a:fontRef>
-        </p:style>
-        <p:txBody>
-          <a:bodyPr rtlCol="0" anchor="ctr"/>
-          <a:lstStyle/>
-          <a:p>
-            <a:pPr algn="ctr"/>
-          </a:p>
-        </p:txBody>
-      </p:sp>
-      <p:sp>
-        <p:nvSpPr>
-          <p:cNvPr id="11" name="TextBox 10"/>
-          <p:cNvSpPr txBox="1"/>
-          <p:nvPr/>
-        </p:nvSpPr>
-        <p:spPr>
-          <a:xfrm>
-            <a:off x="822960" y="3163824"/>
-            <a:ext cx="5120640" cy="420623"/>
-          </a:xfrm>
-          <a:prstGeom prst="rect">
-            <a:avLst/>
-          </a:prstGeom>
-          <a:noFill/>
-        </p:spPr>
-        <p:txBody>
-          <a:bodyPr wrap="square" lIns="73152" rIns="73152">
-            <a:spAutoFit/>
-          </a:bodyPr>
-          <a:lstStyle/>
-          <a:p>
-            <a:pPr algn="l">
-              <a:defRPr sz="1700" b="1">
-                <a:solidFill>
-                  <a:srgbClr val="0F172A"/>
-                </a:solidFill>
-                <a:latin typeface="Arial"/>
-              </a:defRPr>
-            </a:pPr>
-            <a:r>
-              <a:t>2. Hai bàn chân đặt bằng phẳng trên sàn</a:t>
-            </a:r>
-          </a:p>
-        </p:txBody>
-      </p:sp>
-      <p:sp>
-        <p:nvSpPr>
-          <p:cNvPr id="12" name="Rounded Rectangle 11"/>
-          <p:cNvSpPr/>
-          <p:nvPr/>
-        </p:nvSpPr>
-        <p:spPr>
-          <a:xfrm>
-            <a:off x="457200" y="3822191"/>
-            <a:ext cx="5669280" cy="640080"/>
-          </a:xfrm>
-          <a:prstGeom prst="roundRect">
-            <a:avLst/>
-          </a:prstGeom>
-          <a:solidFill>
-            <a:srgbClr val="FFFFFF"/>
-          </a:solidFill>
-          <a:ln w="19050">
-            <a:solidFill>
-              <a:srgbClr val="059669"/>
-            </a:solidFill>
-          </a:ln>
-        </p:spPr>
-        <p:style>
-          <a:lnRef idx="1">
-            <a:schemeClr val="accent1"/>
-          </a:lnRef>
-          <a:fillRef idx="3">
-            <a:schemeClr val="accent1"/>
-          </a:fillRef>
-          <a:effectRef idx="2">
-            <a:schemeClr val="accent1"/>
-          </a:effectRef>
-          <a:fontRef idx="minor">
-            <a:schemeClr val="lt1"/>
-          </a:fontRef>
-        </p:style>
-        <p:txBody>
-          <a:bodyPr rtlCol="0" anchor="ctr"/>
-          <a:lstStyle/>
-          <a:p>
-            <a:pPr algn="ctr"/>
-          </a:p>
-        </p:txBody>
-      </p:sp>
-      <p:sp>
-        <p:nvSpPr>
-          <p:cNvPr id="13" name="Rectangle 12"/>
-          <p:cNvSpPr/>
-          <p:nvPr/>
-        </p:nvSpPr>
-        <p:spPr>
-          <a:xfrm>
-            <a:off x="457200" y="3822191"/>
-            <a:ext cx="182880" cy="640080"/>
-          </a:xfrm>
-          <a:prstGeom prst="rect">
-            <a:avLst/>
-          </a:prstGeom>
-          <a:solidFill>
-            <a:srgbClr val="059669"/>
-          </a:solidFill>
-          <a:ln>
-            <a:noFill/>
-          </a:ln>
-        </p:spPr>
-        <p:style>
-          <a:lnRef idx="1">
-            <a:schemeClr val="accent1"/>
-          </a:lnRef>
-          <a:fillRef idx="3">
-            <a:schemeClr val="accent1"/>
-          </a:fillRef>
-          <a:effectRef idx="2">
-            <a:schemeClr val="accent1"/>
-          </a:effectRef>
-          <a:fontRef idx="minor">
-            <a:schemeClr val="lt1"/>
-          </a:fontRef>
-        </p:style>
-        <p:txBody>
-          <a:bodyPr rtlCol="0" anchor="ctr"/>
-          <a:lstStyle/>
-          <a:p>
-            <a:pPr algn="ctr"/>
-          </a:p>
-        </p:txBody>
-      </p:sp>
-      <p:sp>
-        <p:nvSpPr>
-          <p:cNvPr id="14" name="TextBox 13"/>
-          <p:cNvSpPr txBox="1"/>
-          <p:nvPr/>
-        </p:nvSpPr>
-        <p:spPr>
-          <a:xfrm>
-            <a:off x="822960" y="3931920"/>
-            <a:ext cx="5120640" cy="420623"/>
-          </a:xfrm>
-          <a:prstGeom prst="rect">
-            <a:avLst/>
-          </a:prstGeom>
-          <a:noFill/>
-        </p:spPr>
-        <p:txBody>
-          <a:bodyPr wrap="square" lIns="73152" rIns="73152">
-            <a:spAutoFit/>
-          </a:bodyPr>
-          <a:lstStyle/>
-          <a:p>
-            <a:pPr algn="l">
-              <a:defRPr sz="1700" b="1">
-                <a:solidFill>
-                  <a:srgbClr val="0F172A"/>
-                </a:solidFill>
-                <a:latin typeface="Arial"/>
-              </a:defRPr>
-            </a:pPr>
-            <a:r>
               <a:t>3. Mắt cách màn hình bằng 1 cánh tay</a:t>
             </a:r>
           </a:p>
@@ -5444,6 +5008,7 @@
           <a:lstStyle/>
           <a:p>
             <a:pPr algn="ctr"/>
+            <a:endParaRPr/>
           </a:p>
         </p:txBody>
       </p:sp>
@@ -5487,6 +5052,7 @@
           <a:lstStyle/>
           <a:p>
             <a:pPr algn="ctr"/>
+            <a:endParaRPr/>
           </a:p>
         </p:txBody>
       </p:sp>
@@ -5561,8 +5127,8 @@
 </p:sld>
 </file>
 
-<file path=ppt/slides/slide8.xml><?xml version="1.0" encoding="utf-8"?>
-<p:sld xmlns:a="http://schemas.openxmlformats.org/drawingml/2006/main" xmlns:p="http://schemas.openxmlformats.org/presentationml/2006/main" xmlns:r="http://schemas.openxmlformats.org/officeDocument/2006/relationships">
+<file path=ppt/slides/slide5.xml><?xml version="1.0" encoding="utf-8"?>
+<p:sld xmlns:a="http://schemas.openxmlformats.org/drawingml/2006/main" xmlns:r="http://schemas.openxmlformats.org/officeDocument/2006/relationships" xmlns:p="http://schemas.openxmlformats.org/presentationml/2006/main">
   <p:cSld>
     <p:spTree>
       <p:nvGrpSpPr>
@@ -5570,7 +5136,14 @@
         <p:cNvGrpSpPr/>
         <p:nvPr/>
       </p:nvGrpSpPr>
-      <p:grpSpPr/>
+      <p:grpSpPr>
+        <a:xfrm>
+          <a:off x="0" y="0"/>
+          <a:ext cx="0" cy="0"/>
+          <a:chOff x="0" y="0"/>
+          <a:chExt cx="0" cy="0"/>
+        </a:xfrm>
+      </p:grpSpPr>
       <p:sp>
         <p:nvSpPr>
           <p:cNvPr id="2" name="Rectangle 1"/>
@@ -5611,6 +5184,7 @@
           <a:lstStyle/>
           <a:p>
             <a:pPr algn="ctr"/>
+            <a:endParaRPr/>
           </a:p>
         </p:txBody>
       </p:sp>
@@ -5654,6 +5228,7 @@
           <a:lstStyle/>
           <a:p>
             <a:pPr algn="ctr"/>
+            <a:endParaRPr/>
           </a:p>
         </p:txBody>
       </p:sp>
@@ -5735,6 +5310,7 @@
           <a:lstStyle/>
           <a:p>
             <a:pPr algn="ctr"/>
+            <a:endParaRPr/>
           </a:p>
         </p:txBody>
       </p:sp>
@@ -5895,6 +5471,7 @@
           <a:lstStyle/>
           <a:p>
             <a:pPr algn="ctr"/>
+            <a:endParaRPr/>
           </a:p>
         </p:txBody>
       </p:sp>
@@ -5938,6 +5515,7 @@
           <a:lstStyle/>
           <a:p>
             <a:pPr algn="ctr"/>
+            <a:endParaRPr/>
           </a:p>
         </p:txBody>
       </p:sp>
@@ -5988,8 +5566,8 @@
 </p:sld>
 </file>
 
-<file path=ppt/slides/slide9.xml><?xml version="1.0" encoding="utf-8"?>
-<p:sld xmlns:a="http://schemas.openxmlformats.org/drawingml/2006/main" xmlns:p="http://schemas.openxmlformats.org/presentationml/2006/main" xmlns:r="http://schemas.openxmlformats.org/officeDocument/2006/relationships">
+<file path=ppt/slides/slide6.xml><?xml version="1.0" encoding="utf-8"?>
+<p:sld xmlns:a="http://schemas.openxmlformats.org/drawingml/2006/main" xmlns:r="http://schemas.openxmlformats.org/officeDocument/2006/relationships" xmlns:p="http://schemas.openxmlformats.org/presentationml/2006/main">
   <p:cSld>
     <p:spTree>
       <p:nvGrpSpPr>
@@ -5997,7 +5575,14 @@
         <p:cNvGrpSpPr/>
         <p:nvPr/>
       </p:nvGrpSpPr>
-      <p:grpSpPr/>
+      <p:grpSpPr>
+        <a:xfrm>
+          <a:off x="0" y="0"/>
+          <a:ext cx="0" cy="0"/>
+          <a:chOff x="0" y="0"/>
+          <a:chExt cx="0" cy="0"/>
+        </a:xfrm>
+      </p:grpSpPr>
       <p:sp>
         <p:nvSpPr>
           <p:cNvPr id="2" name="Rectangle 1"/>
@@ -6038,6 +5623,7 @@
           <a:lstStyle/>
           <a:p>
             <a:pPr algn="ctr"/>
+            <a:endParaRPr/>
           </a:p>
         </p:txBody>
       </p:sp>
@@ -6081,6 +5667,7 @@
           <a:lstStyle/>
           <a:p>
             <a:pPr algn="ctr"/>
+            <a:endParaRPr/>
           </a:p>
         </p:txBody>
       </p:sp>
@@ -6198,6 +5785,7 @@
           <a:lstStyle/>
           <a:p>
             <a:pPr algn="ctr"/>
+            <a:endParaRPr/>
           </a:p>
         </p:txBody>
       </p:sp>
@@ -6241,6 +5829,7 @@
           <a:lstStyle/>
           <a:p>
             <a:pPr algn="ctr"/>
+            <a:endParaRPr/>
           </a:p>
         </p:txBody>
       </p:sp>
@@ -6322,6 +5911,7 @@
           <a:lstStyle/>
           <a:p>
             <a:pPr algn="ctr"/>
+            <a:endParaRPr/>
           </a:p>
         </p:txBody>
       </p:sp>
@@ -6365,6 +5955,7 @@
           <a:lstStyle/>
           <a:p>
             <a:pPr algn="ctr"/>
+            <a:endParaRPr/>
           </a:p>
         </p:txBody>
       </p:sp>
@@ -6446,6 +6037,7 @@
           <a:lstStyle/>
           <a:p>
             <a:pPr algn="ctr"/>
+            <a:endParaRPr/>
           </a:p>
         </p:txBody>
       </p:sp>
@@ -6489,6 +6081,7 @@
           <a:lstStyle/>
           <a:p>
             <a:pPr algn="ctr"/>
+            <a:endParaRPr/>
           </a:p>
         </p:txBody>
       </p:sp>
@@ -6570,6 +6163,7 @@
           <a:lstStyle/>
           <a:p>
             <a:pPr algn="ctr"/>
+            <a:endParaRPr/>
           </a:p>
         </p:txBody>
       </p:sp>
@@ -6613,6 +6207,7 @@
           <a:lstStyle/>
           <a:p>
             <a:pPr algn="ctr"/>
+            <a:endParaRPr/>
           </a:p>
         </p:txBody>
       </p:sp>
@@ -6658,7 +6253,151 @@
     <a:masterClrMapping/>
   </p:clrMapOvr>
   <p:transition spd="med">
-    <p:push dir="l"/>
+    <p:push/>
+  </p:transition>
+</p:sld>
+</file>
+
+<file path=ppt/slides/slide7.xml><?xml version="1.0" encoding="utf-8"?>
+<p:sld xmlns:a="http://schemas.openxmlformats.org/drawingml/2006/main" xmlns:r="http://schemas.openxmlformats.org/officeDocument/2006/relationships" xmlns:p="http://schemas.openxmlformats.org/presentationml/2006/main">
+  <p:cSld>
+    <p:spTree>
+      <p:nvGrpSpPr>
+        <p:cNvPr id="1" name=""/>
+        <p:cNvGrpSpPr/>
+        <p:nvPr/>
+      </p:nvGrpSpPr>
+      <p:grpSpPr>
+        <a:xfrm>
+          <a:off x="0" y="0"/>
+          <a:ext cx="0" cy="0"/>
+          <a:chOff x="0" y="0"/>
+          <a:chExt cx="0" cy="0"/>
+        </a:xfrm>
+      </p:grpSpPr>
+      <p:sp>
+        <p:nvSpPr>
+          <p:cNvPr id="2" name="Rectangle 1"/>
+          <p:cNvSpPr/>
+          <p:nvPr/>
+        </p:nvSpPr>
+        <p:spPr>
+          <a:xfrm>
+            <a:off x="0" y="1051560"/>
+            <a:ext cx="12188952" cy="4754879"/>
+          </a:xfrm>
+          <a:prstGeom prst="rect">
+            <a:avLst/>
+          </a:prstGeom>
+          <a:solidFill>
+            <a:srgbClr val="1B4F9B"/>
+          </a:solidFill>
+          <a:ln>
+            <a:noFill/>
+          </a:ln>
+        </p:spPr>
+        <p:style>
+          <a:lnRef idx="1">
+            <a:schemeClr val="accent1"/>
+          </a:lnRef>
+          <a:fillRef idx="3">
+            <a:schemeClr val="accent1"/>
+          </a:fillRef>
+          <a:effectRef idx="2">
+            <a:schemeClr val="accent1"/>
+          </a:effectRef>
+          <a:fontRef idx="minor">
+            <a:schemeClr val="lt1"/>
+          </a:fontRef>
+        </p:style>
+        <p:txBody>
+          <a:bodyPr rtlCol="0" anchor="ctr"/>
+          <a:lstStyle/>
+          <a:p>
+            <a:pPr algn="ctr"/>
+            <a:endParaRPr/>
+          </a:p>
+        </p:txBody>
+      </p:sp>
+      <p:sp>
+        <p:nvSpPr>
+          <p:cNvPr id="3" name="TextBox 2"/>
+          <p:cNvSpPr txBox="1"/>
+          <p:nvPr/>
+        </p:nvSpPr>
+        <p:spPr>
+          <a:xfrm>
+            <a:off x="914400" y="1828800"/>
+            <a:ext cx="10360152" cy="1097280"/>
+          </a:xfrm>
+          <a:prstGeom prst="rect">
+            <a:avLst/>
+          </a:prstGeom>
+          <a:noFill/>
+        </p:spPr>
+        <p:txBody>
+          <a:bodyPr wrap="square" lIns="73152" rIns="73152">
+            <a:spAutoFit/>
+          </a:bodyPr>
+          <a:lstStyle/>
+          <a:p>
+            <a:pPr algn="ctr">
+              <a:defRPr sz="3600" b="1">
+                <a:solidFill>
+                  <a:srgbClr val="FFFFFF"/>
+                </a:solidFill>
+                <a:latin typeface="Arial"/>
+              </a:defRPr>
+            </a:pPr>
+            <a:r>
+              <a:t>Các con giỏi lắm! 🌟</a:t>
+            </a:r>
+          </a:p>
+        </p:txBody>
+      </p:sp>
+      <p:sp>
+        <p:nvSpPr>
+          <p:cNvPr id="4" name="TextBox 3"/>
+          <p:cNvSpPr txBox="1"/>
+          <p:nvPr/>
+        </p:nvSpPr>
+        <p:spPr>
+          <a:xfrm>
+            <a:off x="914400" y="3200400"/>
+            <a:ext cx="10360152" cy="914400"/>
+          </a:xfrm>
+          <a:prstGeom prst="rect">
+            <a:avLst/>
+          </a:prstGeom>
+          <a:noFill/>
+        </p:spPr>
+        <p:txBody>
+          <a:bodyPr wrap="square" lIns="73152" rIns="73152">
+            <a:spAutoFit/>
+          </a:bodyPr>
+          <a:lstStyle/>
+          <a:p>
+            <a:pPr algn="ctr">
+              <a:defRPr sz="2200" b="0">
+                <a:solidFill>
+                  <a:srgbClr val="FFFFFF"/>
+                </a:solidFill>
+                <a:latin typeface="Arial"/>
+              </a:defRPr>
+            </a:pPr>
+            <a:r>
+              <a:t>BTVN: Hãy nhắc nhở bố mẹ và anh chị ngồi đúng tư thế nhé!</a:t>
+            </a:r>
+          </a:p>
+        </p:txBody>
+      </p:sp>
+    </p:spTree>
+  </p:cSld>
+  <p:clrMapOvr>
+    <a:masterClrMapping/>
+  </p:clrMapOvr>
+  <p:transition spd="med">
+    <p:fade/>
   </p:transition>
 </p:sld>
 </file>

</xml_diff>